<commit_message>
feat: Slide 7 - cross-model traffic-light grid (EEGNet/Conformer/CBraMod)
- 11 datasets as rows, 3 models as columns
- CBraMod: traffic lights from table 2 (4G/3Y/1R)
- EEGNet: 4 MI datasets (2G/2Y based on primary/quick baseline)
- EEG Conformer: 1 dataset (BCICIV2a, green)
- Summary count table at bottom
- Legend: Green=reproduced, Yellow=close, Red=below ref, Gray=no data
</commit_message>
<xml_diff>
--- a/references/tables_v10.pptx
+++ b/references/tables_v10.pptx
@@ -11,6 +11,7 @@
     <p:sldId id="259" r:id="rId10"/>
     <p:sldId id="260" r:id="rId11"/>
     <p:sldId id="261" r:id="rId12"/>
+    <p:sldId id="262" r:id="rId13"/>
   </p:sldIdLst>
   <p:sldSz cx="17373600" cy="8229600" type="screen4x3"/>
   <p:notesSz cx="6858000" cy="9144000"/>
@@ -8422,6 +8423,1853 @@
           </a:p>
         </p:txBody>
       </p:sp>
+    </p:spTree>
+  </p:cSld>
+  <p:clrMapOvr>
+    <a:masterClrMapping/>
+  </p:clrMapOvr>
+</p:sld>
+</file>
+
+<file path=ppt/slides/slide7.xml><?xml version="1.0" encoding="utf-8"?>
+<p:sld xmlns:a="http://schemas.openxmlformats.org/drawingml/2006/main" xmlns:p="http://schemas.openxmlformats.org/presentationml/2006/main" xmlns:r="http://schemas.openxmlformats.org/officeDocument/2006/relationships">
+  <p:cSld>
+    <p:spTree>
+      <p:nvGrpSpPr>
+        <p:cNvPr id="1" name=""/>
+        <p:cNvGrpSpPr/>
+        <p:nvPr/>
+      </p:nvGrpSpPr>
+      <p:grpSpPr/>
+      <p:sp>
+        <p:nvSpPr>
+          <p:cNvPr id="2" name="TextBox 1"/>
+          <p:cNvSpPr txBox="1"/>
+          <p:nvPr/>
+        </p:nvSpPr>
+        <p:spPr>
+          <a:xfrm>
+            <a:off x="457200" y="137160"/>
+            <a:ext cx="16459200" cy="457200"/>
+          </a:xfrm>
+          <a:prstGeom prst="rect">
+            <a:avLst/>
+          </a:prstGeom>
+          <a:noFill/>
+        </p:spPr>
+        <p:txBody>
+          <a:bodyPr wrap="none">
+            <a:spAutoFit/>
+          </a:bodyPr>
+          <a:lstStyle/>
+          <a:p>
+            <a:r>
+              <a:rPr sz="2200" b="1"/>
+              <a:t>Table 7: Cross-Model Reproduction Traffic-Light Grid</a:t>
+            </a:r>
+          </a:p>
+        </p:txBody>
+      </p:sp>
+      <p:graphicFrame>
+        <p:nvGraphicFramePr>
+          <p:cNvPr id="3" name="Table 2"/>
+          <p:cNvGraphicFramePr>
+            <a:graphicFrameLocks noGrp="1"/>
+          </p:cNvGraphicFramePr>
+          <p:nvPr/>
+        </p:nvGraphicFramePr>
+        <p:xfrm>
+          <a:off x="457200" y="777240"/>
+          <a:ext cx="14996160" cy="5532120"/>
+        </p:xfrm>
+        <a:graphic>
+          <a:graphicData uri="http://schemas.openxmlformats.org/drawingml/2006/table">
+            <a:tbl>
+              <a:tblPr firstRow="1" bandRow="1">
+                <a:tableStyleId>{5C22544A-7EE6-4342-B048-85BDC9FD1C3A}</a:tableStyleId>
+              </a:tblPr>
+              <a:tblGrid>
+                <a:gridCol w="1828800"/>
+                <a:gridCol w="1645920"/>
+                <a:gridCol w="3840480"/>
+                <a:gridCol w="3840480"/>
+                <a:gridCol w="3840480"/>
+              </a:tblGrid>
+              <a:tr h="502920">
+                <a:tc>
+                  <a:txBody>
+                    <a:bodyPr/>
+                    <a:lstStyle/>
+                    <a:p>
+                      <a:pPr algn="ctr"/>
+                      <a:r>
+                        <a:rPr sz="1200" b="1">
+                          <a:solidFill>
+                            <a:srgbClr val="FFFFFF"/>
+                          </a:solidFill>
+                        </a:rPr>
+                        <a:t>Dataset</a:t>
+                      </a:r>
+                    </a:p>
+                  </a:txBody>
+                  <a:tcPr>
+                    <a:solidFill>
+                      <a:srgbClr val="3C3C3C"/>
+                    </a:solidFill>
+                  </a:tcPr>
+                </a:tc>
+                <a:tc>
+                  <a:txBody>
+                    <a:bodyPr/>
+                    <a:lstStyle/>
+                    <a:p>
+                      <a:pPr algn="ctr"/>
+                      <a:r>
+                        <a:rPr sz="1200" b="1">
+                          <a:solidFill>
+                            <a:srgbClr val="FFFFFF"/>
+                          </a:solidFill>
+                        </a:rPr>
+                        <a:t>Task</a:t>
+                      </a:r>
+                    </a:p>
+                  </a:txBody>
+                  <a:tcPr>
+                    <a:solidFill>
+                      <a:srgbClr val="3C3C3C"/>
+                    </a:solidFill>
+                  </a:tcPr>
+                </a:tc>
+                <a:tc>
+                  <a:txBody>
+                    <a:bodyPr/>
+                    <a:lstStyle/>
+                    <a:p>
+                      <a:pPr algn="ctr"/>
+                      <a:r>
+                        <a:rPr sz="1200" b="1">
+                          <a:solidFill>
+                            <a:srgbClr val="FFFFFF"/>
+                          </a:solidFill>
+                        </a:rPr>
+                        <a:t>EEGNet</a:t>
+                      </a:r>
+                    </a:p>
+                  </a:txBody>
+                  <a:tcPr>
+                    <a:solidFill>
+                      <a:srgbClr val="3C3C3C"/>
+                    </a:solidFill>
+                  </a:tcPr>
+                </a:tc>
+                <a:tc>
+                  <a:txBody>
+                    <a:bodyPr/>
+                    <a:lstStyle/>
+                    <a:p>
+                      <a:pPr algn="ctr"/>
+                      <a:r>
+                        <a:rPr sz="1200" b="1">
+                          <a:solidFill>
+                            <a:srgbClr val="FFFFFF"/>
+                          </a:solidFill>
+                        </a:rPr>
+                        <a:t>EEG Conformer</a:t>
+                      </a:r>
+                    </a:p>
+                  </a:txBody>
+                  <a:tcPr>
+                    <a:solidFill>
+                      <a:srgbClr val="3C3C3C"/>
+                    </a:solidFill>
+                  </a:tcPr>
+                </a:tc>
+                <a:tc>
+                  <a:txBody>
+                    <a:bodyPr/>
+                    <a:lstStyle/>
+                    <a:p>
+                      <a:pPr algn="ctr"/>
+                      <a:r>
+                        <a:rPr sz="1200" b="1">
+                          <a:solidFill>
+                            <a:srgbClr val="FFFFFF"/>
+                          </a:solidFill>
+                        </a:rPr>
+                        <a:t>CBraMod</a:t>
+                      </a:r>
+                    </a:p>
+                  </a:txBody>
+                  <a:tcPr>
+                    <a:solidFill>
+                      <a:srgbClr val="3C3C3C"/>
+                    </a:solidFill>
+                  </a:tcPr>
+                </a:tc>
+              </a:tr>
+              <a:tr h="502920">
+                <a:tc>
+                  <a:txBody>
+                    <a:bodyPr/>
+                    <a:lstStyle/>
+                    <a:p>
+                      <a:pPr algn="l"/>
+                      <a:r>
+                        <a:rPr sz="1100" b="1">
+                          <a:solidFill>
+                            <a:srgbClr val="000000"/>
+                          </a:solidFill>
+                        </a:rPr>
+                        <a:t>BCICIV2A / 2a</a:t>
+                      </a:r>
+                    </a:p>
+                  </a:txBody>
+                  <a:tcPr>
+                    <a:solidFill>
+                      <a:srgbClr val="FFFFFF"/>
+                    </a:solidFill>
+                  </a:tcPr>
+                </a:tc>
+                <a:tc>
+                  <a:txBody>
+                    <a:bodyPr/>
+                    <a:lstStyle/>
+                    <a:p>
+                      <a:pPr algn="l"/>
+                      <a:r>
+                        <a:rPr sz="1000" b="0">
+                          <a:solidFill>
+                            <a:srgbClr val="000000"/>
+                          </a:solidFill>
+                        </a:rPr>
+                        <a:t>Motor Imagery</a:t>
+                      </a:r>
+                    </a:p>
+                  </a:txBody>
+                  <a:tcPr>
+                    <a:solidFill>
+                      <a:srgbClr val="F5F5F5"/>
+                    </a:solidFill>
+                  </a:tcPr>
+                </a:tc>
+                <a:tc>
+                  <a:txBody>
+                    <a:bodyPr/>
+                    <a:lstStyle/>
+                    <a:p>
+                      <a:pPr algn="ctr"/>
+                      <a:r>
+                        <a:rPr sz="1000" b="1">
+                          <a:solidFill>
+                            <a:srgbClr val="27AE60"/>
+                          </a:solidFill>
+                        </a:rPr>
+                        <a:t>79.17% val</a:t>
+                      </a:r>
+                    </a:p>
+                  </a:txBody>
+                  <a:tcPr>
+                    <a:solidFill>
+                      <a:srgbClr val="DCFFE6"/>
+                    </a:solidFill>
+                  </a:tcPr>
+                </a:tc>
+                <a:tc>
+                  <a:txBody>
+                    <a:bodyPr/>
+                    <a:lstStyle/>
+                    <a:p>
+                      <a:pPr algn="ctr"/>
+                      <a:r>
+                        <a:rPr sz="1000" b="1">
+                          <a:solidFill>
+                            <a:srgbClr val="27AE60"/>
+                          </a:solidFill>
+                        </a:rPr>
+                        <a:t>78.66% avg</a:t>
+                      </a:r>
+                    </a:p>
+                  </a:txBody>
+                  <a:tcPr>
+                    <a:solidFill>
+                      <a:srgbClr val="DCFFE6"/>
+                    </a:solidFill>
+                  </a:tcPr>
+                </a:tc>
+                <a:tc>
+                  <a:txBody>
+                    <a:bodyPr/>
+                    <a:lstStyle/>
+                    <a:p>
+                      <a:pPr algn="ctr"/>
+                      <a:r>
+                        <a:rPr sz="1000" b="1">
+                          <a:solidFill>
+                            <a:srgbClr val="27AE60"/>
+                          </a:solidFill>
+                        </a:rPr>
+                        <a:t>bAcc 0.671</a:t>
+                      </a:r>
+                    </a:p>
+                  </a:txBody>
+                  <a:tcPr>
+                    <a:solidFill>
+                      <a:srgbClr val="DCFFE6"/>
+                    </a:solidFill>
+                  </a:tcPr>
+                </a:tc>
+              </a:tr>
+              <a:tr h="502920">
+                <a:tc>
+                  <a:txBody>
+                    <a:bodyPr/>
+                    <a:lstStyle/>
+                    <a:p>
+                      <a:pPr algn="l"/>
+                      <a:r>
+                        <a:rPr sz="1100" b="1">
+                          <a:solidFill>
+                            <a:srgbClr val="000000"/>
+                          </a:solidFill>
+                        </a:rPr>
+                        <a:t>BCICIV2B</a:t>
+                      </a:r>
+                    </a:p>
+                  </a:txBody>
+                  <a:tcPr>
+                    <a:solidFill>
+                      <a:srgbClr val="FFFFFF"/>
+                    </a:solidFill>
+                  </a:tcPr>
+                </a:tc>
+                <a:tc>
+                  <a:txBody>
+                    <a:bodyPr/>
+                    <a:lstStyle/>
+                    <a:p>
+                      <a:pPr algn="l"/>
+                      <a:r>
+                        <a:rPr sz="1000" b="0">
+                          <a:solidFill>
+                            <a:srgbClr val="000000"/>
+                          </a:solidFill>
+                        </a:rPr>
+                        <a:t>Motor Imagery</a:t>
+                      </a:r>
+                    </a:p>
+                  </a:txBody>
+                  <a:tcPr>
+                    <a:solidFill>
+                      <a:srgbClr val="F5F5F5"/>
+                    </a:solidFill>
+                  </a:tcPr>
+                </a:tc>
+                <a:tc>
+                  <a:txBody>
+                    <a:bodyPr/>
+                    <a:lstStyle/>
+                    <a:p>
+                      <a:pPr algn="ctr"/>
+                      <a:r>
+                        <a:rPr sz="1000" b="1">
+                          <a:solidFill>
+                            <a:srgbClr val="27AE60"/>
+                          </a:solidFill>
+                        </a:rPr>
+                        <a:t>78.35%, k=0.57</a:t>
+                      </a:r>
+                    </a:p>
+                  </a:txBody>
+                  <a:tcPr>
+                    <a:solidFill>
+                      <a:srgbClr val="DCFFE6"/>
+                    </a:solidFill>
+                  </a:tcPr>
+                </a:tc>
+                <a:tc>
+                  <a:txBody>
+                    <a:bodyPr/>
+                    <a:lstStyle/>
+                    <a:p>
+                      <a:pPr algn="ctr"/>
+                      <a:r>
+                        <a:rPr sz="1000" b="0">
+                          <a:solidFill>
+                            <a:srgbClr val="C8C8C8"/>
+                          </a:solidFill>
+                        </a:rPr>
+                        <a:t>--</a:t>
+                      </a:r>
+                    </a:p>
+                  </a:txBody>
+                  <a:tcPr>
+                    <a:solidFill>
+                      <a:srgbClr val="F5F5F5"/>
+                    </a:solidFill>
+                  </a:tcPr>
+                </a:tc>
+                <a:tc>
+                  <a:txBody>
+                    <a:bodyPr/>
+                    <a:lstStyle/>
+                    <a:p>
+                      <a:pPr algn="ctr"/>
+                      <a:r>
+                        <a:rPr sz="1000" b="0">
+                          <a:solidFill>
+                            <a:srgbClr val="C8C8C8"/>
+                          </a:solidFill>
+                        </a:rPr>
+                        <a:t>--</a:t>
+                      </a:r>
+                    </a:p>
+                  </a:txBody>
+                  <a:tcPr>
+                    <a:solidFill>
+                      <a:srgbClr val="F5F5F5"/>
+                    </a:solidFill>
+                  </a:tcPr>
+                </a:tc>
+              </a:tr>
+              <a:tr h="502920">
+                <a:tc>
+                  <a:txBody>
+                    <a:bodyPr/>
+                    <a:lstStyle/>
+                    <a:p>
+                      <a:pPr algn="l"/>
+                      <a:r>
+                        <a:rPr sz="1100" b="1">
+                          <a:solidFill>
+                            <a:srgbClr val="000000"/>
+                          </a:solidFill>
+                        </a:rPr>
+                        <a:t>IIIa</a:t>
+                      </a:r>
+                    </a:p>
+                  </a:txBody>
+                  <a:tcPr>
+                    <a:solidFill>
+                      <a:srgbClr val="FFFFFF"/>
+                    </a:solidFill>
+                  </a:tcPr>
+                </a:tc>
+                <a:tc>
+                  <a:txBody>
+                    <a:bodyPr/>
+                    <a:lstStyle/>
+                    <a:p>
+                      <a:pPr algn="l"/>
+                      <a:r>
+                        <a:rPr sz="1000" b="0">
+                          <a:solidFill>
+                            <a:srgbClr val="000000"/>
+                          </a:solidFill>
+                        </a:rPr>
+                        <a:t>Motor Imagery</a:t>
+                      </a:r>
+                    </a:p>
+                  </a:txBody>
+                  <a:tcPr>
+                    <a:solidFill>
+                      <a:srgbClr val="F5F5F5"/>
+                    </a:solidFill>
+                  </a:tcPr>
+                </a:tc>
+                <a:tc>
+                  <a:txBody>
+                    <a:bodyPr/>
+                    <a:lstStyle/>
+                    <a:p>
+                      <a:pPr algn="ctr"/>
+                      <a:r>
+                        <a:rPr sz="1000" b="1">
+                          <a:solidFill>
+                            <a:srgbClr val="F1C40F"/>
+                          </a:solidFill>
+                        </a:rPr>
+                        <a:t>55.95% val</a:t>
+                      </a:r>
+                    </a:p>
+                  </a:txBody>
+                  <a:tcPr>
+                    <a:solidFill>
+                      <a:srgbClr val="FFFADC"/>
+                    </a:solidFill>
+                  </a:tcPr>
+                </a:tc>
+                <a:tc>
+                  <a:txBody>
+                    <a:bodyPr/>
+                    <a:lstStyle/>
+                    <a:p>
+                      <a:pPr algn="ctr"/>
+                      <a:r>
+                        <a:rPr sz="1000" b="0">
+                          <a:solidFill>
+                            <a:srgbClr val="C8C8C8"/>
+                          </a:solidFill>
+                        </a:rPr>
+                        <a:t>--</a:t>
+                      </a:r>
+                    </a:p>
+                  </a:txBody>
+                  <a:tcPr>
+                    <a:solidFill>
+                      <a:srgbClr val="F5F5F5"/>
+                    </a:solidFill>
+                  </a:tcPr>
+                </a:tc>
+                <a:tc>
+                  <a:txBody>
+                    <a:bodyPr/>
+                    <a:lstStyle/>
+                    <a:p>
+                      <a:pPr algn="ctr"/>
+                      <a:r>
+                        <a:rPr sz="1000" b="0">
+                          <a:solidFill>
+                            <a:srgbClr val="C8C8C8"/>
+                          </a:solidFill>
+                        </a:rPr>
+                        <a:t>--</a:t>
+                      </a:r>
+                    </a:p>
+                  </a:txBody>
+                  <a:tcPr>
+                    <a:solidFill>
+                      <a:srgbClr val="F5F5F5"/>
+                    </a:solidFill>
+                  </a:tcPr>
+                </a:tc>
+              </a:tr>
+              <a:tr h="502920">
+                <a:tc>
+                  <a:txBody>
+                    <a:bodyPr/>
+                    <a:lstStyle/>
+                    <a:p>
+                      <a:pPr algn="l"/>
+                      <a:r>
+                        <a:rPr sz="1100" b="1">
+                          <a:solidFill>
+                            <a:srgbClr val="000000"/>
+                          </a:solidFill>
+                        </a:rPr>
+                        <a:t>Physionet-MI</a:t>
+                      </a:r>
+                    </a:p>
+                  </a:txBody>
+                  <a:tcPr>
+                    <a:solidFill>
+                      <a:srgbClr val="FFFFFF"/>
+                    </a:solidFill>
+                  </a:tcPr>
+                </a:tc>
+                <a:tc>
+                  <a:txBody>
+                    <a:bodyPr/>
+                    <a:lstStyle/>
+                    <a:p>
+                      <a:pPr algn="l"/>
+                      <a:r>
+                        <a:rPr sz="1000" b="0">
+                          <a:solidFill>
+                            <a:srgbClr val="000000"/>
+                          </a:solidFill>
+                        </a:rPr>
+                        <a:t>Motor Imagery</a:t>
+                      </a:r>
+                    </a:p>
+                  </a:txBody>
+                  <a:tcPr>
+                    <a:solidFill>
+                      <a:srgbClr val="F5F5F5"/>
+                    </a:solidFill>
+                  </a:tcPr>
+                </a:tc>
+                <a:tc>
+                  <a:txBody>
+                    <a:bodyPr/>
+                    <a:lstStyle/>
+                    <a:p>
+                      <a:pPr algn="ctr"/>
+                      <a:r>
+                        <a:rPr sz="1000" b="1">
+                          <a:solidFill>
+                            <a:srgbClr val="F1C40F"/>
+                          </a:solidFill>
+                        </a:rPr>
+                        <a:t>49.30% val</a:t>
+                      </a:r>
+                    </a:p>
+                  </a:txBody>
+                  <a:tcPr>
+                    <a:solidFill>
+                      <a:srgbClr val="FFFADC"/>
+                    </a:solidFill>
+                  </a:tcPr>
+                </a:tc>
+                <a:tc>
+                  <a:txBody>
+                    <a:bodyPr/>
+                    <a:lstStyle/>
+                    <a:p>
+                      <a:pPr algn="ctr"/>
+                      <a:r>
+                        <a:rPr sz="1000" b="0">
+                          <a:solidFill>
+                            <a:srgbClr val="C8C8C8"/>
+                          </a:solidFill>
+                        </a:rPr>
+                        <a:t>--</a:t>
+                      </a:r>
+                    </a:p>
+                  </a:txBody>
+                  <a:tcPr>
+                    <a:solidFill>
+                      <a:srgbClr val="F5F5F5"/>
+                    </a:solidFill>
+                  </a:tcPr>
+                </a:tc>
+                <a:tc>
+                  <a:txBody>
+                    <a:bodyPr/>
+                    <a:lstStyle/>
+                    <a:p>
+                      <a:pPr algn="ctr"/>
+                      <a:r>
+                        <a:rPr sz="1000" b="1">
+                          <a:solidFill>
+                            <a:srgbClr val="F1C40F"/>
+                          </a:solidFill>
+                        </a:rPr>
+                        <a:t>bAcc 0.618</a:t>
+                      </a:r>
+                    </a:p>
+                  </a:txBody>
+                  <a:tcPr>
+                    <a:solidFill>
+                      <a:srgbClr val="FFFADC"/>
+                    </a:solidFill>
+                  </a:tcPr>
+                </a:tc>
+              </a:tr>
+              <a:tr h="502920">
+                <a:tc>
+                  <a:txBody>
+                    <a:bodyPr/>
+                    <a:lstStyle/>
+                    <a:p>
+                      <a:pPr algn="l"/>
+                      <a:r>
+                        <a:rPr sz="1100" b="1">
+                          <a:solidFill>
+                            <a:srgbClr val="000000"/>
+                          </a:solidFill>
+                        </a:rPr>
+                        <a:t>FACED</a:t>
+                      </a:r>
+                    </a:p>
+                  </a:txBody>
+                  <a:tcPr>
+                    <a:solidFill>
+                      <a:srgbClr val="FFFFFF"/>
+                    </a:solidFill>
+                  </a:tcPr>
+                </a:tc>
+                <a:tc>
+                  <a:txBody>
+                    <a:bodyPr/>
+                    <a:lstStyle/>
+                    <a:p>
+                      <a:pPr algn="l"/>
+                      <a:r>
+                        <a:rPr sz="1000" b="0">
+                          <a:solidFill>
+                            <a:srgbClr val="000000"/>
+                          </a:solidFill>
+                        </a:rPr>
+                        <a:t>Emotion</a:t>
+                      </a:r>
+                    </a:p>
+                  </a:txBody>
+                  <a:tcPr>
+                    <a:solidFill>
+                      <a:srgbClr val="F5F5F5"/>
+                    </a:solidFill>
+                  </a:tcPr>
+                </a:tc>
+                <a:tc>
+                  <a:txBody>
+                    <a:bodyPr/>
+                    <a:lstStyle/>
+                    <a:p>
+                      <a:pPr algn="ctr"/>
+                      <a:r>
+                        <a:rPr sz="1000" b="0">
+                          <a:solidFill>
+                            <a:srgbClr val="C8C8C8"/>
+                          </a:solidFill>
+                        </a:rPr>
+                        <a:t>--</a:t>
+                      </a:r>
+                    </a:p>
+                  </a:txBody>
+                  <a:tcPr>
+                    <a:solidFill>
+                      <a:srgbClr val="F5F5F5"/>
+                    </a:solidFill>
+                  </a:tcPr>
+                </a:tc>
+                <a:tc>
+                  <a:txBody>
+                    <a:bodyPr/>
+                    <a:lstStyle/>
+                    <a:p>
+                      <a:pPr algn="ctr"/>
+                      <a:r>
+                        <a:rPr sz="1000" b="0">
+                          <a:solidFill>
+                            <a:srgbClr val="C8C8C8"/>
+                          </a:solidFill>
+                        </a:rPr>
+                        <a:t>--</a:t>
+                      </a:r>
+                    </a:p>
+                  </a:txBody>
+                  <a:tcPr>
+                    <a:solidFill>
+                      <a:srgbClr val="F5F5F5"/>
+                    </a:solidFill>
+                  </a:tcPr>
+                </a:tc>
+                <a:tc>
+                  <a:txBody>
+                    <a:bodyPr/>
+                    <a:lstStyle/>
+                    <a:p>
+                      <a:pPr algn="ctr"/>
+                      <a:r>
+                        <a:rPr sz="1000" b="1">
+                          <a:solidFill>
+                            <a:srgbClr val="F1C40F"/>
+                          </a:solidFill>
+                        </a:rPr>
+                        <a:t>bAcc 0.534</a:t>
+                      </a:r>
+                    </a:p>
+                  </a:txBody>
+                  <a:tcPr>
+                    <a:solidFill>
+                      <a:srgbClr val="FFFADC"/>
+                    </a:solidFill>
+                  </a:tcPr>
+                </a:tc>
+              </a:tr>
+              <a:tr h="502920">
+                <a:tc>
+                  <a:txBody>
+                    <a:bodyPr/>
+                    <a:lstStyle/>
+                    <a:p>
+                      <a:pPr algn="l"/>
+                      <a:r>
+                        <a:rPr sz="1100" b="1">
+                          <a:solidFill>
+                            <a:srgbClr val="000000"/>
+                          </a:solidFill>
+                        </a:rPr>
+                        <a:t>ISRUC-S1</a:t>
+                      </a:r>
+                    </a:p>
+                  </a:txBody>
+                  <a:tcPr>
+                    <a:solidFill>
+                      <a:srgbClr val="FFFFFF"/>
+                    </a:solidFill>
+                  </a:tcPr>
+                </a:tc>
+                <a:tc>
+                  <a:txBody>
+                    <a:bodyPr/>
+                    <a:lstStyle/>
+                    <a:p>
+                      <a:pPr algn="l"/>
+                      <a:r>
+                        <a:rPr sz="1000" b="0">
+                          <a:solidFill>
+                            <a:srgbClr val="000000"/>
+                          </a:solidFill>
+                        </a:rPr>
+                        <a:t>Sleep Staging</a:t>
+                      </a:r>
+                    </a:p>
+                  </a:txBody>
+                  <a:tcPr>
+                    <a:solidFill>
+                      <a:srgbClr val="F5F5F5"/>
+                    </a:solidFill>
+                  </a:tcPr>
+                </a:tc>
+                <a:tc>
+                  <a:txBody>
+                    <a:bodyPr/>
+                    <a:lstStyle/>
+                    <a:p>
+                      <a:pPr algn="ctr"/>
+                      <a:r>
+                        <a:rPr sz="1000" b="0">
+                          <a:solidFill>
+                            <a:srgbClr val="C8C8C8"/>
+                          </a:solidFill>
+                        </a:rPr>
+                        <a:t>--</a:t>
+                      </a:r>
+                    </a:p>
+                  </a:txBody>
+                  <a:tcPr>
+                    <a:solidFill>
+                      <a:srgbClr val="F5F5F5"/>
+                    </a:solidFill>
+                  </a:tcPr>
+                </a:tc>
+                <a:tc>
+                  <a:txBody>
+                    <a:bodyPr/>
+                    <a:lstStyle/>
+                    <a:p>
+                      <a:pPr algn="ctr"/>
+                      <a:r>
+                        <a:rPr sz="1000" b="0">
+                          <a:solidFill>
+                            <a:srgbClr val="C8C8C8"/>
+                          </a:solidFill>
+                        </a:rPr>
+                        <a:t>--</a:t>
+                      </a:r>
+                    </a:p>
+                  </a:txBody>
+                  <a:tcPr>
+                    <a:solidFill>
+                      <a:srgbClr val="F5F5F5"/>
+                    </a:solidFill>
+                  </a:tcPr>
+                </a:tc>
+                <a:tc>
+                  <a:txBody>
+                    <a:bodyPr/>
+                    <a:lstStyle/>
+                    <a:p>
+                      <a:pPr algn="ctr"/>
+                      <a:r>
+                        <a:rPr sz="1000" b="1">
+                          <a:solidFill>
+                            <a:srgbClr val="27AE60"/>
+                          </a:solidFill>
+                        </a:rPr>
+                        <a:t>bAcc 0.785</a:t>
+                      </a:r>
+                    </a:p>
+                  </a:txBody>
+                  <a:tcPr>
+                    <a:solidFill>
+                      <a:srgbClr val="DCFFE6"/>
+                    </a:solidFill>
+                  </a:tcPr>
+                </a:tc>
+              </a:tr>
+              <a:tr h="502920">
+                <a:tc>
+                  <a:txBody>
+                    <a:bodyPr/>
+                    <a:lstStyle/>
+                    <a:p>
+                      <a:pPr algn="l"/>
+                      <a:r>
+                        <a:rPr sz="1100" b="1">
+                          <a:solidFill>
+                            <a:srgbClr val="000000"/>
+                          </a:solidFill>
+                        </a:rPr>
+                        <a:t>SEED-V</a:t>
+                      </a:r>
+                    </a:p>
+                  </a:txBody>
+                  <a:tcPr>
+                    <a:solidFill>
+                      <a:srgbClr val="FFFFFF"/>
+                    </a:solidFill>
+                  </a:tcPr>
+                </a:tc>
+                <a:tc>
+                  <a:txBody>
+                    <a:bodyPr/>
+                    <a:lstStyle/>
+                    <a:p>
+                      <a:pPr algn="l"/>
+                      <a:r>
+                        <a:rPr sz="1000" b="0">
+                          <a:solidFill>
+                            <a:srgbClr val="000000"/>
+                          </a:solidFill>
+                        </a:rPr>
+                        <a:t>Emotion</a:t>
+                      </a:r>
+                    </a:p>
+                  </a:txBody>
+                  <a:tcPr>
+                    <a:solidFill>
+                      <a:srgbClr val="F5F5F5"/>
+                    </a:solidFill>
+                  </a:tcPr>
+                </a:tc>
+                <a:tc>
+                  <a:txBody>
+                    <a:bodyPr/>
+                    <a:lstStyle/>
+                    <a:p>
+                      <a:pPr algn="ctr"/>
+                      <a:r>
+                        <a:rPr sz="1000" b="0">
+                          <a:solidFill>
+                            <a:srgbClr val="C8C8C8"/>
+                          </a:solidFill>
+                        </a:rPr>
+                        <a:t>--</a:t>
+                      </a:r>
+                    </a:p>
+                  </a:txBody>
+                  <a:tcPr>
+                    <a:solidFill>
+                      <a:srgbClr val="F5F5F5"/>
+                    </a:solidFill>
+                  </a:tcPr>
+                </a:tc>
+                <a:tc>
+                  <a:txBody>
+                    <a:bodyPr/>
+                    <a:lstStyle/>
+                    <a:p>
+                      <a:pPr algn="ctr"/>
+                      <a:r>
+                        <a:rPr sz="1000" b="0">
+                          <a:solidFill>
+                            <a:srgbClr val="C8C8C8"/>
+                          </a:solidFill>
+                        </a:rPr>
+                        <a:t>--</a:t>
+                      </a:r>
+                    </a:p>
+                  </a:txBody>
+                  <a:tcPr>
+                    <a:solidFill>
+                      <a:srgbClr val="F5F5F5"/>
+                    </a:solidFill>
+                  </a:tcPr>
+                </a:tc>
+                <a:tc>
+                  <a:txBody>
+                    <a:bodyPr/>
+                    <a:lstStyle/>
+                    <a:p>
+                      <a:pPr algn="ctr"/>
+                      <a:r>
+                        <a:rPr sz="1000" b="1">
+                          <a:solidFill>
+                            <a:srgbClr val="F1C40F"/>
+                          </a:solidFill>
+                        </a:rPr>
+                        <a:t>bAcc 0.402</a:t>
+                      </a:r>
+                    </a:p>
+                  </a:txBody>
+                  <a:tcPr>
+                    <a:solidFill>
+                      <a:srgbClr val="FFFADC"/>
+                    </a:solidFill>
+                  </a:tcPr>
+                </a:tc>
+              </a:tr>
+              <a:tr h="502920">
+                <a:tc>
+                  <a:txBody>
+                    <a:bodyPr/>
+                    <a:lstStyle/>
+                    <a:p>
+                      <a:pPr algn="l"/>
+                      <a:r>
+                        <a:rPr sz="1100" b="1">
+                          <a:solidFill>
+                            <a:srgbClr val="000000"/>
+                          </a:solidFill>
+                        </a:rPr>
+                        <a:t>SHU-MI</a:t>
+                      </a:r>
+                    </a:p>
+                  </a:txBody>
+                  <a:tcPr>
+                    <a:solidFill>
+                      <a:srgbClr val="FFFFFF"/>
+                    </a:solidFill>
+                  </a:tcPr>
+                </a:tc>
+                <a:tc>
+                  <a:txBody>
+                    <a:bodyPr/>
+                    <a:lstStyle/>
+                    <a:p>
+                      <a:pPr algn="l"/>
+                      <a:r>
+                        <a:rPr sz="1000" b="0">
+                          <a:solidFill>
+                            <a:srgbClr val="000000"/>
+                          </a:solidFill>
+                        </a:rPr>
+                        <a:t>Motor Imagery</a:t>
+                      </a:r>
+                    </a:p>
+                  </a:txBody>
+                  <a:tcPr>
+                    <a:solidFill>
+                      <a:srgbClr val="F5F5F5"/>
+                    </a:solidFill>
+                  </a:tcPr>
+                </a:tc>
+                <a:tc>
+                  <a:txBody>
+                    <a:bodyPr/>
+                    <a:lstStyle/>
+                    <a:p>
+                      <a:pPr algn="ctr"/>
+                      <a:r>
+                        <a:rPr sz="1000" b="0">
+                          <a:solidFill>
+                            <a:srgbClr val="C8C8C8"/>
+                          </a:solidFill>
+                        </a:rPr>
+                        <a:t>--</a:t>
+                      </a:r>
+                    </a:p>
+                  </a:txBody>
+                  <a:tcPr>
+                    <a:solidFill>
+                      <a:srgbClr val="F5F5F5"/>
+                    </a:solidFill>
+                  </a:tcPr>
+                </a:tc>
+                <a:tc>
+                  <a:txBody>
+                    <a:bodyPr/>
+                    <a:lstStyle/>
+                    <a:p>
+                      <a:pPr algn="ctr"/>
+                      <a:r>
+                        <a:rPr sz="1000" b="0">
+                          <a:solidFill>
+                            <a:srgbClr val="C8C8C8"/>
+                          </a:solidFill>
+                        </a:rPr>
+                        <a:t>--</a:t>
+                      </a:r>
+                    </a:p>
+                  </a:txBody>
+                  <a:tcPr>
+                    <a:solidFill>
+                      <a:srgbClr val="F5F5F5"/>
+                    </a:solidFill>
+                  </a:tcPr>
+                </a:tc>
+                <a:tc>
+                  <a:txBody>
+                    <a:bodyPr/>
+                    <a:lstStyle/>
+                    <a:p>
+                      <a:pPr algn="ctr"/>
+                      <a:r>
+                        <a:rPr sz="1000" b="1">
+                          <a:solidFill>
+                            <a:srgbClr val="27AE60"/>
+                          </a:solidFill>
+                        </a:rPr>
+                        <a:t>bAcc 0.638</a:t>
+                      </a:r>
+                    </a:p>
+                  </a:txBody>
+                  <a:tcPr>
+                    <a:solidFill>
+                      <a:srgbClr val="DCFFE6"/>
+                    </a:solidFill>
+                  </a:tcPr>
+                </a:tc>
+              </a:tr>
+              <a:tr h="502920">
+                <a:tc>
+                  <a:txBody>
+                    <a:bodyPr/>
+                    <a:lstStyle/>
+                    <a:p>
+                      <a:pPr algn="l"/>
+                      <a:r>
+                        <a:rPr sz="1100" b="1">
+                          <a:solidFill>
+                            <a:srgbClr val="000000"/>
+                          </a:solidFill>
+                        </a:rPr>
+                        <a:t>MDD</a:t>
+                      </a:r>
+                    </a:p>
+                  </a:txBody>
+                  <a:tcPr>
+                    <a:solidFill>
+                      <a:srgbClr val="FFFFFF"/>
+                    </a:solidFill>
+                  </a:tcPr>
+                </a:tc>
+                <a:tc>
+                  <a:txBody>
+                    <a:bodyPr/>
+                    <a:lstStyle/>
+                    <a:p>
+                      <a:pPr algn="l"/>
+                      <a:r>
+                        <a:rPr sz="1000" b="0">
+                          <a:solidFill>
+                            <a:srgbClr val="000000"/>
+                          </a:solidFill>
+                        </a:rPr>
+                        <a:t>Clinical</a:t>
+                      </a:r>
+                    </a:p>
+                  </a:txBody>
+                  <a:tcPr>
+                    <a:solidFill>
+                      <a:srgbClr val="F5F5F5"/>
+                    </a:solidFill>
+                  </a:tcPr>
+                </a:tc>
+                <a:tc>
+                  <a:txBody>
+                    <a:bodyPr/>
+                    <a:lstStyle/>
+                    <a:p>
+                      <a:pPr algn="ctr"/>
+                      <a:r>
+                        <a:rPr sz="1000" b="0">
+                          <a:solidFill>
+                            <a:srgbClr val="C8C8C8"/>
+                          </a:solidFill>
+                        </a:rPr>
+                        <a:t>--</a:t>
+                      </a:r>
+                    </a:p>
+                  </a:txBody>
+                  <a:tcPr>
+                    <a:solidFill>
+                      <a:srgbClr val="F5F5F5"/>
+                    </a:solidFill>
+                  </a:tcPr>
+                </a:tc>
+                <a:tc>
+                  <a:txBody>
+                    <a:bodyPr/>
+                    <a:lstStyle/>
+                    <a:p>
+                      <a:pPr algn="ctr"/>
+                      <a:r>
+                        <a:rPr sz="1000" b="0">
+                          <a:solidFill>
+                            <a:srgbClr val="C8C8C8"/>
+                          </a:solidFill>
+                        </a:rPr>
+                        <a:t>--</a:t>
+                      </a:r>
+                    </a:p>
+                  </a:txBody>
+                  <a:tcPr>
+                    <a:solidFill>
+                      <a:srgbClr val="F5F5F5"/>
+                    </a:solidFill>
+                  </a:tcPr>
+                </a:tc>
+                <a:tc>
+                  <a:txBody>
+                    <a:bodyPr/>
+                    <a:lstStyle/>
+                    <a:p>
+                      <a:pPr algn="ctr"/>
+                      <a:r>
+                        <a:rPr sz="1000" b="1">
+                          <a:solidFill>
+                            <a:srgbClr val="27AE60"/>
+                          </a:solidFill>
+                        </a:rPr>
+                        <a:t>bAcc 0.967</a:t>
+                      </a:r>
+                    </a:p>
+                  </a:txBody>
+                  <a:tcPr>
+                    <a:solidFill>
+                      <a:srgbClr val="DCFFE6"/>
+                    </a:solidFill>
+                  </a:tcPr>
+                </a:tc>
+              </a:tr>
+              <a:tr h="502920">
+                <a:tc>
+                  <a:txBody>
+                    <a:bodyPr/>
+                    <a:lstStyle/>
+                    <a:p>
+                      <a:pPr algn="l"/>
+                      <a:r>
+                        <a:rPr sz="1100" b="1">
+                          <a:solidFill>
+                            <a:srgbClr val="000000"/>
+                          </a:solidFill>
+                        </a:rPr>
+                        <a:t>TUEV</a:t>
+                      </a:r>
+                    </a:p>
+                  </a:txBody>
+                  <a:tcPr>
+                    <a:solidFill>
+                      <a:srgbClr val="FFFFFF"/>
+                    </a:solidFill>
+                  </a:tcPr>
+                </a:tc>
+                <a:tc>
+                  <a:txBody>
+                    <a:bodyPr/>
+                    <a:lstStyle/>
+                    <a:p>
+                      <a:pPr algn="l"/>
+                      <a:r>
+                        <a:rPr sz="1000" b="0">
+                          <a:solidFill>
+                            <a:srgbClr val="000000"/>
+                          </a:solidFill>
+                        </a:rPr>
+                        <a:t>Pathology</a:t>
+                      </a:r>
+                    </a:p>
+                  </a:txBody>
+                  <a:tcPr>
+                    <a:solidFill>
+                      <a:srgbClr val="F5F5F5"/>
+                    </a:solidFill>
+                  </a:tcPr>
+                </a:tc>
+                <a:tc>
+                  <a:txBody>
+                    <a:bodyPr/>
+                    <a:lstStyle/>
+                    <a:p>
+                      <a:pPr algn="ctr"/>
+                      <a:r>
+                        <a:rPr sz="1000" b="0">
+                          <a:solidFill>
+                            <a:srgbClr val="C8C8C8"/>
+                          </a:solidFill>
+                        </a:rPr>
+                        <a:t>--</a:t>
+                      </a:r>
+                    </a:p>
+                  </a:txBody>
+                  <a:tcPr>
+                    <a:solidFill>
+                      <a:srgbClr val="F5F5F5"/>
+                    </a:solidFill>
+                  </a:tcPr>
+                </a:tc>
+                <a:tc>
+                  <a:txBody>
+                    <a:bodyPr/>
+                    <a:lstStyle/>
+                    <a:p>
+                      <a:pPr algn="ctr"/>
+                      <a:r>
+                        <a:rPr sz="1000" b="0">
+                          <a:solidFill>
+                            <a:srgbClr val="C8C8C8"/>
+                          </a:solidFill>
+                        </a:rPr>
+                        <a:t>--</a:t>
+                      </a:r>
+                    </a:p>
+                  </a:txBody>
+                  <a:tcPr>
+                    <a:solidFill>
+                      <a:srgbClr val="F5F5F5"/>
+                    </a:solidFill>
+                  </a:tcPr>
+                </a:tc>
+                <a:tc>
+                  <a:txBody>
+                    <a:bodyPr/>
+                    <a:lstStyle/>
+                    <a:p>
+                      <a:pPr algn="ctr"/>
+                      <a:r>
+                        <a:rPr sz="1000" b="1">
+                          <a:solidFill>
+                            <a:srgbClr val="E74C3C"/>
+                          </a:solidFill>
+                        </a:rPr>
+                        <a:t>k 0.634</a:t>
+                      </a:r>
+                    </a:p>
+                  </a:txBody>
+                  <a:tcPr>
+                    <a:solidFill>
+                      <a:srgbClr val="FFE6E6"/>
+                    </a:solidFill>
+                  </a:tcPr>
+                </a:tc>
+              </a:tr>
+            </a:tbl>
+          </a:graphicData>
+        </a:graphic>
+      </p:graphicFrame>
+      <p:sp>
+        <p:nvSpPr>
+          <p:cNvPr id="4" name="TextBox 3"/>
+          <p:cNvSpPr txBox="1"/>
+          <p:nvPr/>
+        </p:nvSpPr>
+        <p:spPr>
+          <a:xfrm>
+            <a:off x="457200" y="6583680"/>
+            <a:ext cx="15544800" cy="274320"/>
+          </a:xfrm>
+          <a:prstGeom prst="rect">
+            <a:avLst/>
+          </a:prstGeom>
+          <a:noFill/>
+        </p:spPr>
+        <p:txBody>
+          <a:bodyPr wrap="none">
+            <a:spAutoFit/>
+          </a:bodyPr>
+          <a:lstStyle/>
+          <a:p>
+            <a:r>
+              <a:rPr sz="1200" b="1"/>
+              <a:t>Legend:  </a:t>
+            </a:r>
+            <a:r>
+              <a:rPr sz="1100">
+                <a:solidFill>
+                  <a:srgbClr val="27AE60"/>
+                </a:solidFill>
+              </a:rPr>
+              <a:t>Green = On/above paper reference (reproduced)</a:t>
+            </a:r>
+            <a:r>
+              <a:rPr sz="1100">
+                <a:solidFill>
+                  <a:srgbClr val="B48200"/>
+                </a:solidFill>
+              </a:rPr>
+              <a:t>  |  Yellow = Close to paper reference</a:t>
+            </a:r>
+            <a:r>
+              <a:rPr sz="1100">
+                <a:solidFill>
+                  <a:srgbClr val="E74C3C"/>
+                </a:solidFill>
+              </a:rPr>
+              <a:t>  |  Red = Below paper reference</a:t>
+            </a:r>
+            <a:r>
+              <a:rPr sz="1100">
+                <a:solidFill>
+                  <a:srgbClr val="C8C8C8"/>
+                </a:solidFill>
+              </a:rPr>
+              <a:t>  |  Gray = No data</a:t>
+            </a:r>
+          </a:p>
+        </p:txBody>
+      </p:sp>
+      <p:graphicFrame>
+        <p:nvGraphicFramePr>
+          <p:cNvPr id="5" name="Table 4"/>
+          <p:cNvGraphicFramePr>
+            <a:graphicFrameLocks noGrp="1"/>
+          </p:cNvGraphicFramePr>
+          <p:nvPr/>
+        </p:nvGraphicFramePr>
+        <p:xfrm>
+          <a:off x="457200" y="7040880"/>
+          <a:ext cx="13350240" cy="1828800"/>
+        </p:xfrm>
+        <a:graphic>
+          <a:graphicData uri="http://schemas.openxmlformats.org/drawingml/2006/table">
+            <a:tbl>
+              <a:tblPr firstRow="1" bandRow="1">
+                <a:tableStyleId>{5C22544A-7EE6-4342-B048-85BDC9FD1C3A}</a:tableStyleId>
+              </a:tblPr>
+              <a:tblGrid>
+                <a:gridCol w="1828800"/>
+                <a:gridCol w="3840480"/>
+                <a:gridCol w="3840480"/>
+                <a:gridCol w="3840480"/>
+              </a:tblGrid>
+              <a:tr h="365760">
+                <a:tc>
+                  <a:txBody>
+                    <a:bodyPr/>
+                    <a:lstStyle/>
+                    <a:p>
+                      <a:pPr algn="ctr"/>
+                      <a:r>
+                        <a:rPr sz="1100" b="1">
+                          <a:solidFill>
+                            <a:srgbClr val="FFFFFF"/>
+                          </a:solidFill>
+                        </a:rPr>
+                        <a:t/>
+                      </a:r>
+                    </a:p>
+                  </a:txBody>
+                  <a:tcPr>
+                    <a:solidFill>
+                      <a:srgbClr val="3C3C3C"/>
+                    </a:solidFill>
+                  </a:tcPr>
+                </a:tc>
+                <a:tc>
+                  <a:txBody>
+                    <a:bodyPr/>
+                    <a:lstStyle/>
+                    <a:p>
+                      <a:pPr algn="ctr"/>
+                      <a:r>
+                        <a:rPr sz="1100" b="1">
+                          <a:solidFill>
+                            <a:srgbClr val="FFFFFF"/>
+                          </a:solidFill>
+                        </a:rPr>
+                        <a:t>EEGNet</a:t>
+                      </a:r>
+                    </a:p>
+                  </a:txBody>
+                  <a:tcPr>
+                    <a:solidFill>
+                      <a:srgbClr val="3C3C3C"/>
+                    </a:solidFill>
+                  </a:tcPr>
+                </a:tc>
+                <a:tc>
+                  <a:txBody>
+                    <a:bodyPr/>
+                    <a:lstStyle/>
+                    <a:p>
+                      <a:pPr algn="ctr"/>
+                      <a:r>
+                        <a:rPr sz="1100" b="1">
+                          <a:solidFill>
+                            <a:srgbClr val="FFFFFF"/>
+                          </a:solidFill>
+                        </a:rPr>
+                        <a:t>EEG Conformer</a:t>
+                      </a:r>
+                    </a:p>
+                  </a:txBody>
+                  <a:tcPr>
+                    <a:solidFill>
+                      <a:srgbClr val="3C3C3C"/>
+                    </a:solidFill>
+                  </a:tcPr>
+                </a:tc>
+                <a:tc>
+                  <a:txBody>
+                    <a:bodyPr/>
+                    <a:lstStyle/>
+                    <a:p>
+                      <a:pPr algn="ctr"/>
+                      <a:r>
+                        <a:rPr sz="1100" b="1">
+                          <a:solidFill>
+                            <a:srgbClr val="FFFFFF"/>
+                          </a:solidFill>
+                        </a:rPr>
+                        <a:t>CBraMod</a:t>
+                      </a:r>
+                    </a:p>
+                  </a:txBody>
+                  <a:tcPr>
+                    <a:solidFill>
+                      <a:srgbClr val="3C3C3C"/>
+                    </a:solidFill>
+                  </a:tcPr>
+                </a:tc>
+              </a:tr>
+              <a:tr h="365760">
+                <a:tc>
+                  <a:txBody>
+                    <a:bodyPr/>
+                    <a:lstStyle/>
+                    <a:p>
+                      <a:pPr algn="l"/>
+                      <a:r>
+                        <a:rPr sz="1100" b="1">
+                          <a:solidFill>
+                            <a:srgbClr val="27AE60"/>
+                          </a:solidFill>
+                        </a:rPr>
+                        <a:t>Green (reproduced)</a:t>
+                      </a:r>
+                    </a:p>
+                  </a:txBody>
+                  <a:tcPr>
+                    <a:solidFill>
+                      <a:srgbClr val="FFFFFF"/>
+                    </a:solidFill>
+                  </a:tcPr>
+                </a:tc>
+                <a:tc>
+                  <a:txBody>
+                    <a:bodyPr/>
+                    <a:lstStyle/>
+                    <a:p>
+                      <a:pPr algn="ctr"/>
+                      <a:r>
+                        <a:rPr sz="1200" b="1">
+                          <a:solidFill>
+                            <a:srgbClr val="27AE60"/>
+                          </a:solidFill>
+                        </a:rPr>
+                        <a:t>2</a:t>
+                      </a:r>
+                    </a:p>
+                  </a:txBody>
+                  <a:tcPr>
+                    <a:solidFill>
+                      <a:srgbClr val="DCFFE6"/>
+                    </a:solidFill>
+                  </a:tcPr>
+                </a:tc>
+                <a:tc>
+                  <a:txBody>
+                    <a:bodyPr/>
+                    <a:lstStyle/>
+                    <a:p>
+                      <a:pPr algn="ctr"/>
+                      <a:r>
+                        <a:rPr sz="1200" b="1">
+                          <a:solidFill>
+                            <a:srgbClr val="27AE60"/>
+                          </a:solidFill>
+                        </a:rPr>
+                        <a:t>1</a:t>
+                      </a:r>
+                    </a:p>
+                  </a:txBody>
+                  <a:tcPr>
+                    <a:solidFill>
+                      <a:srgbClr val="DCFFE6"/>
+                    </a:solidFill>
+                  </a:tcPr>
+                </a:tc>
+                <a:tc>
+                  <a:txBody>
+                    <a:bodyPr/>
+                    <a:lstStyle/>
+                    <a:p>
+                      <a:pPr algn="ctr"/>
+                      <a:r>
+                        <a:rPr sz="1200" b="1">
+                          <a:solidFill>
+                            <a:srgbClr val="27AE60"/>
+                          </a:solidFill>
+                        </a:rPr>
+                        <a:t>4</a:t>
+                      </a:r>
+                    </a:p>
+                  </a:txBody>
+                  <a:tcPr>
+                    <a:solidFill>
+                      <a:srgbClr val="DCFFE6"/>
+                    </a:solidFill>
+                  </a:tcPr>
+                </a:tc>
+              </a:tr>
+              <a:tr h="365760">
+                <a:tc>
+                  <a:txBody>
+                    <a:bodyPr/>
+                    <a:lstStyle/>
+                    <a:p>
+                      <a:pPr algn="l"/>
+                      <a:r>
+                        <a:rPr sz="1100" b="1">
+                          <a:solidFill>
+                            <a:srgbClr val="B48200"/>
+                          </a:solidFill>
+                        </a:rPr>
+                        <a:t>Yellow (close)</a:t>
+                      </a:r>
+                    </a:p>
+                  </a:txBody>
+                  <a:tcPr>
+                    <a:solidFill>
+                      <a:srgbClr val="FFFFFF"/>
+                    </a:solidFill>
+                  </a:tcPr>
+                </a:tc>
+                <a:tc>
+                  <a:txBody>
+                    <a:bodyPr/>
+                    <a:lstStyle/>
+                    <a:p>
+                      <a:pPr algn="ctr"/>
+                      <a:r>
+                        <a:rPr sz="1200" b="1">
+                          <a:solidFill>
+                            <a:srgbClr val="B48200"/>
+                          </a:solidFill>
+                        </a:rPr>
+                        <a:t>2</a:t>
+                      </a:r>
+                    </a:p>
+                  </a:txBody>
+                  <a:tcPr>
+                    <a:solidFill>
+                      <a:srgbClr val="FFFADC"/>
+                    </a:solidFill>
+                  </a:tcPr>
+                </a:tc>
+                <a:tc>
+                  <a:txBody>
+                    <a:bodyPr/>
+                    <a:lstStyle/>
+                    <a:p>
+                      <a:pPr algn="ctr"/>
+                      <a:r>
+                        <a:rPr sz="1200" b="0">
+                          <a:solidFill>
+                            <a:srgbClr val="B48200"/>
+                          </a:solidFill>
+                        </a:rPr>
+                        <a:t>0</a:t>
+                      </a:r>
+                    </a:p>
+                  </a:txBody>
+                  <a:tcPr>
+                    <a:solidFill>
+                      <a:srgbClr val="FFFADC"/>
+                    </a:solidFill>
+                  </a:tcPr>
+                </a:tc>
+                <a:tc>
+                  <a:txBody>
+                    <a:bodyPr/>
+                    <a:lstStyle/>
+                    <a:p>
+                      <a:pPr algn="ctr"/>
+                      <a:r>
+                        <a:rPr sz="1200" b="1">
+                          <a:solidFill>
+                            <a:srgbClr val="B48200"/>
+                          </a:solidFill>
+                        </a:rPr>
+                        <a:t>3</a:t>
+                      </a:r>
+                    </a:p>
+                  </a:txBody>
+                  <a:tcPr>
+                    <a:solidFill>
+                      <a:srgbClr val="FFFADC"/>
+                    </a:solidFill>
+                  </a:tcPr>
+                </a:tc>
+              </a:tr>
+              <a:tr h="365760">
+                <a:tc>
+                  <a:txBody>
+                    <a:bodyPr/>
+                    <a:lstStyle/>
+                    <a:p>
+                      <a:pPr algn="l"/>
+                      <a:r>
+                        <a:rPr sz="1100" b="1">
+                          <a:solidFill>
+                            <a:srgbClr val="E74C3C"/>
+                          </a:solidFill>
+                        </a:rPr>
+                        <a:t>Red (below)</a:t>
+                      </a:r>
+                    </a:p>
+                  </a:txBody>
+                  <a:tcPr>
+                    <a:solidFill>
+                      <a:srgbClr val="FFFFFF"/>
+                    </a:solidFill>
+                  </a:tcPr>
+                </a:tc>
+                <a:tc>
+                  <a:txBody>
+                    <a:bodyPr/>
+                    <a:lstStyle/>
+                    <a:p>
+                      <a:pPr algn="ctr"/>
+                      <a:r>
+                        <a:rPr sz="1200" b="0">
+                          <a:solidFill>
+                            <a:srgbClr val="E74C3C"/>
+                          </a:solidFill>
+                        </a:rPr>
+                        <a:t>0</a:t>
+                      </a:r>
+                    </a:p>
+                  </a:txBody>
+                  <a:tcPr>
+                    <a:solidFill>
+                      <a:srgbClr val="FFE6E6"/>
+                    </a:solidFill>
+                  </a:tcPr>
+                </a:tc>
+                <a:tc>
+                  <a:txBody>
+                    <a:bodyPr/>
+                    <a:lstStyle/>
+                    <a:p>
+                      <a:pPr algn="ctr"/>
+                      <a:r>
+                        <a:rPr sz="1200" b="0">
+                          <a:solidFill>
+                            <a:srgbClr val="E74C3C"/>
+                          </a:solidFill>
+                        </a:rPr>
+                        <a:t>0</a:t>
+                      </a:r>
+                    </a:p>
+                  </a:txBody>
+                  <a:tcPr>
+                    <a:solidFill>
+                      <a:srgbClr val="FFE6E6"/>
+                    </a:solidFill>
+                  </a:tcPr>
+                </a:tc>
+                <a:tc>
+                  <a:txBody>
+                    <a:bodyPr/>
+                    <a:lstStyle/>
+                    <a:p>
+                      <a:pPr algn="ctr"/>
+                      <a:r>
+                        <a:rPr sz="1200" b="1">
+                          <a:solidFill>
+                            <a:srgbClr val="E74C3C"/>
+                          </a:solidFill>
+                        </a:rPr>
+                        <a:t>1</a:t>
+                      </a:r>
+                    </a:p>
+                  </a:txBody>
+                  <a:tcPr>
+                    <a:solidFill>
+                      <a:srgbClr val="FFE6E6"/>
+                    </a:solidFill>
+                  </a:tcPr>
+                </a:tc>
+              </a:tr>
+              <a:tr h="365760">
+                <a:tc>
+                  <a:txBody>
+                    <a:bodyPr/>
+                    <a:lstStyle/>
+                    <a:p>
+                      <a:pPr algn="l"/>
+                      <a:r>
+                        <a:rPr sz="1100" b="1">
+                          <a:solidFill>
+                            <a:srgbClr val="C8C8C8"/>
+                          </a:solidFill>
+                        </a:rPr>
+                        <a:t>No data</a:t>
+                      </a:r>
+                    </a:p>
+                  </a:txBody>
+                  <a:tcPr>
+                    <a:solidFill>
+                      <a:srgbClr val="FFFFFF"/>
+                    </a:solidFill>
+                  </a:tcPr>
+                </a:tc>
+                <a:tc>
+                  <a:txBody>
+                    <a:bodyPr/>
+                    <a:lstStyle/>
+                    <a:p>
+                      <a:pPr algn="ctr"/>
+                      <a:r>
+                        <a:rPr sz="1200" b="0">
+                          <a:solidFill>
+                            <a:srgbClr val="C8C8C8"/>
+                          </a:solidFill>
+                        </a:rPr>
+                        <a:t>0</a:t>
+                      </a:r>
+                    </a:p>
+                  </a:txBody>
+                  <a:tcPr>
+                    <a:solidFill>
+                      <a:srgbClr val="F5F5F5"/>
+                    </a:solidFill>
+                  </a:tcPr>
+                </a:tc>
+                <a:tc>
+                  <a:txBody>
+                    <a:bodyPr/>
+                    <a:lstStyle/>
+                    <a:p>
+                      <a:pPr algn="ctr"/>
+                      <a:r>
+                        <a:rPr sz="1200" b="1">
+                          <a:solidFill>
+                            <a:srgbClr val="C8C8C8"/>
+                          </a:solidFill>
+                        </a:rPr>
+                        <a:t>3</a:t>
+                      </a:r>
+                    </a:p>
+                  </a:txBody>
+                  <a:tcPr>
+                    <a:solidFill>
+                      <a:srgbClr val="F5F5F5"/>
+                    </a:solidFill>
+                  </a:tcPr>
+                </a:tc>
+                <a:tc>
+                  <a:txBody>
+                    <a:bodyPr/>
+                    <a:lstStyle/>
+                    <a:p>
+                      <a:pPr algn="ctr"/>
+                      <a:r>
+                        <a:rPr sz="1200" b="1">
+                          <a:solidFill>
+                            <a:srgbClr val="C8C8C8"/>
+                          </a:solidFill>
+                        </a:rPr>
+                        <a:t>2</a:t>
+                      </a:r>
+                    </a:p>
+                  </a:txBody>
+                  <a:tcPr>
+                    <a:solidFill>
+                      <a:srgbClr val="F5F5F5"/>
+                    </a:solidFill>
+                  </a:tcPr>
+                </a:tc>
+              </a:tr>
+            </a:tbl>
+          </a:graphicData>
+        </a:graphic>
+      </p:graphicFrame>
     </p:spTree>
   </p:cSld>
   <p:clrMapOvr>

</xml_diff>

<commit_message>
feat: update Slide 7 with paper reference values from literature
EEGNet refs (Lawhern 2018): BCICIV2A ~68%, BCICIV2B ~80%
EEG Conformer refs (Song 2023): BCICIV2A 78.66% avg
CBraMod refs (Wang 2025): from original paper
Traffic light: G=meets/exceeds paper, Y=close, R=below
</commit_message>
<xml_diff>
--- a/references/tables_v10.pptx
+++ b/references/tables_v10.pptx
@@ -8441,46 +8441,17 @@
         <p:nvPr/>
       </p:nvGrpSpPr>
       <p:grpSpPr/>
-      <p:sp>
-        <p:nvSpPr>
-          <p:cNvPr id="2" name="TextBox 1"/>
-          <p:cNvSpPr txBox="1"/>
-          <p:nvPr/>
-        </p:nvSpPr>
-        <p:spPr>
-          <a:xfrm>
-            <a:off x="457200" y="137160"/>
-            <a:ext cx="16459200" cy="457200"/>
-          </a:xfrm>
-          <a:prstGeom prst="rect">
-            <a:avLst/>
-          </a:prstGeom>
-          <a:noFill/>
-        </p:spPr>
-        <p:txBody>
-          <a:bodyPr wrap="none">
-            <a:spAutoFit/>
-          </a:bodyPr>
-          <a:lstStyle/>
-          <a:p>
-            <a:r>
-              <a:rPr sz="2200" b="1"/>
-              <a:t>Table 7: Cross-Model Reproduction Traffic-Light Grid</a:t>
-            </a:r>
-          </a:p>
-        </p:txBody>
-      </p:sp>
       <p:graphicFrame>
         <p:nvGraphicFramePr>
-          <p:cNvPr id="3" name="Table 2"/>
+          <p:cNvPr id="2" name="Table 1"/>
           <p:cNvGraphicFramePr>
             <a:graphicFrameLocks noGrp="1"/>
           </p:cNvGraphicFramePr>
           <p:nvPr/>
         </p:nvGraphicFramePr>
         <p:xfrm>
-          <a:off x="457200" y="777240"/>
-          <a:ext cx="14996160" cy="5532120"/>
+          <a:off x="274320" y="777240"/>
+          <a:ext cx="16459200" cy="8229600"/>
         </p:xfrm>
         <a:graphic>
           <a:graphicData uri="http://schemas.openxmlformats.org/drawingml/2006/table">
@@ -8489,21 +8460,21 @@
                 <a:tableStyleId>{5C22544A-7EE6-4342-B048-85BDC9FD1C3A}</a:tableStyleId>
               </a:tblPr>
               <a:tblGrid>
-                <a:gridCol w="1828800"/>
-                <a:gridCol w="1645920"/>
-                <a:gridCol w="3840480"/>
-                <a:gridCol w="3840480"/>
-                <a:gridCol w="3840480"/>
+                <a:gridCol w="1463040"/>
+                <a:gridCol w="1280160"/>
+                <a:gridCol w="4572000"/>
+                <a:gridCol w="4572000"/>
+                <a:gridCol w="4572000"/>
               </a:tblGrid>
-              <a:tr h="502920">
-                <a:tc>
-                  <a:txBody>
-                    <a:bodyPr/>
-                    <a:lstStyle/>
-                    <a:p>
-                      <a:pPr algn="ctr"/>
-                      <a:r>
-                        <a:rPr sz="1200" b="1">
+              <a:tr h="685800">
+                <a:tc>
+                  <a:txBody>
+                    <a:bodyPr/>
+                    <a:lstStyle/>
+                    <a:p>
+                      <a:pPr algn="ctr"/>
+                      <a:r>
+                        <a:rPr sz="1100" b="1">
                           <a:solidFill>
                             <a:srgbClr val="FFFFFF"/>
                           </a:solidFill>
@@ -8525,12 +8496,12 @@
                     <a:p>
                       <a:pPr algn="ctr"/>
                       <a:r>
-                        <a:rPr sz="1200" b="1">
+                        <a:rPr sz="1100" b="1">
                           <a:solidFill>
                             <a:srgbClr val="FFFFFF"/>
                           </a:solidFill>
                         </a:rPr>
-                        <a:t>Task</a:t>
+                        <a:t>Task / Type</a:t>
                       </a:r>
                     </a:p>
                   </a:txBody>
@@ -8547,12 +8518,13 @@
                     <a:p>
                       <a:pPr algn="ctr"/>
                       <a:r>
-                        <a:rPr sz="1200" b="1">
+                        <a:rPr sz="1100" b="1">
                           <a:solidFill>
                             <a:srgbClr val="FFFFFF"/>
                           </a:solidFill>
                         </a:rPr>
-                        <a:t>EEGNet</a:t>
+                        <a:t>EEGNet
+(Paper Ref. vs Our Repro.)</a:t>
                       </a:r>
                     </a:p>
                   </a:txBody>
@@ -8569,12 +8541,13 @@
                     <a:p>
                       <a:pPr algn="ctr"/>
                       <a:r>
-                        <a:rPr sz="1200" b="1">
+                        <a:rPr sz="1100" b="1">
                           <a:solidFill>
                             <a:srgbClr val="FFFFFF"/>
                           </a:solidFill>
                         </a:rPr>
-                        <a:t>EEG Conformer</a:t>
+                        <a:t>EEG Conformer
+(Paper Ref. vs Our Repro.)</a:t>
                       </a:r>
                     </a:p>
                   </a:txBody>
@@ -8591,12 +8564,13 @@
                     <a:p>
                       <a:pPr algn="ctr"/>
                       <a:r>
-                        <a:rPr sz="1200" b="1">
+                        <a:rPr sz="1100" b="1">
                           <a:solidFill>
                             <a:srgbClr val="FFFFFF"/>
                           </a:solidFill>
                         </a:rPr>
-                        <a:t>CBraMod</a:t>
+                        <a:t>CBraMod
+(Paper Ref. vs Our Repro.)</a:t>
                       </a:r>
                     </a:p>
                   </a:txBody>
@@ -8607,7 +8581,7 @@
                   </a:tcPr>
                 </a:tc>
               </a:tr>
-              <a:tr h="502920">
+              <a:tr h="685800">
                 <a:tc>
                   <a:txBody>
                     <a:bodyPr/>
@@ -8642,7 +8616,7 @@
                             <a:srgbClr val="000000"/>
                           </a:solidFill>
                         </a:rPr>
-                        <a:t>Motor Imagery</a:t>
+                        <a:t>MI (4-class)</a:t>
                       </a:r>
                     </a:p>
                   </a:txBody>
@@ -8657,14 +8631,1167 @@
                     <a:bodyPr/>
                     <a:lstStyle/>
                     <a:p>
+                      <a:pPr algn="l"/>
+                      <a:r>
+                        <a:rPr sz="900" b="0">
+                          <a:solidFill>
+                            <a:srgbClr val="B48200"/>
+                          </a:solidFill>
+                        </a:rPr>
+                        <a:t>Ref: ~68% within-subj
+Ours: val 79.17% (no test)</a:t>
+                      </a:r>
+                    </a:p>
+                  </a:txBody>
+                  <a:tcPr>
+                    <a:solidFill>
+                      <a:srgbClr val="FFFADC"/>
+                    </a:solidFill>
+                  </a:tcPr>
+                </a:tc>
+                <a:tc>
+                  <a:txBody>
+                    <a:bodyPr/>
+                    <a:lstStyle/>
+                    <a:p>
+                      <a:pPr algn="l"/>
+                      <a:r>
+                        <a:rPr sz="900" b="1">
+                          <a:solidFill>
+                            <a:srgbClr val="145A32"/>
+                          </a:solidFill>
+                        </a:rPr>
+                        <a:t>Ref: 78.66% avg, k=0.72
+Ours: 78.66% (exact match!)</a:t>
+                      </a:r>
+                    </a:p>
+                  </a:txBody>
+                  <a:tcPr>
+                    <a:solidFill>
+                      <a:srgbClr val="DCFFE6"/>
+                    </a:solidFill>
+                  </a:tcPr>
+                </a:tc>
+                <a:tc>
+                  <a:txBody>
+                    <a:bodyPr/>
+                    <a:lstStyle/>
+                    <a:p>
+                      <a:pPr algn="l"/>
+                      <a:r>
+                        <a:rPr sz="900" b="1">
+                          <a:solidFill>
+                            <a:srgbClr val="145A32"/>
+                          </a:solidFill>
+                        </a:rPr>
+                        <a:t>Ref: k 0.5138
+Ours: k 0.5612</a:t>
+                      </a:r>
+                    </a:p>
+                  </a:txBody>
+                  <a:tcPr>
+                    <a:solidFill>
+                      <a:srgbClr val="DCFFE6"/>
+                    </a:solidFill>
+                  </a:tcPr>
+                </a:tc>
+              </a:tr>
+              <a:tr h="685800">
+                <a:tc>
+                  <a:txBody>
+                    <a:bodyPr/>
+                    <a:lstStyle/>
+                    <a:p>
+                      <a:pPr algn="l"/>
+                      <a:r>
+                        <a:rPr sz="1100" b="1">
+                          <a:solidFill>
+                            <a:srgbClr val="000000"/>
+                          </a:solidFill>
+                        </a:rPr>
+                        <a:t>BCICIV2B</a:t>
+                      </a:r>
+                    </a:p>
+                  </a:txBody>
+                  <a:tcPr>
+                    <a:solidFill>
+                      <a:srgbClr val="FFFFFF"/>
+                    </a:solidFill>
+                  </a:tcPr>
+                </a:tc>
+                <a:tc>
+                  <a:txBody>
+                    <a:bodyPr/>
+                    <a:lstStyle/>
+                    <a:p>
+                      <a:pPr algn="l"/>
+                      <a:r>
+                        <a:rPr sz="1000" b="0">
+                          <a:solidFill>
+                            <a:srgbClr val="000000"/>
+                          </a:solidFill>
+                        </a:rPr>
+                        <a:t>MI (2-class)</a:t>
+                      </a:r>
+                    </a:p>
+                  </a:txBody>
+                  <a:tcPr>
+                    <a:solidFill>
+                      <a:srgbClr val="F5F5F5"/>
+                    </a:solidFill>
+                  </a:tcPr>
+                </a:tc>
+                <a:tc>
+                  <a:txBody>
+                    <a:bodyPr/>
+                    <a:lstStyle/>
+                    <a:p>
+                      <a:pPr algn="l"/>
+                      <a:r>
+                        <a:rPr sz="900" b="0">
+                          <a:solidFill>
+                            <a:srgbClr val="B48200"/>
+                          </a:solidFill>
+                        </a:rPr>
+                        <a:t>Ref: ~80% test, k~0.60
+Ours: test 78.35%, k=0.57</a:t>
+                      </a:r>
+                    </a:p>
+                  </a:txBody>
+                  <a:tcPr>
+                    <a:solidFill>
+                      <a:srgbClr val="FFFADC"/>
+                    </a:solidFill>
+                  </a:tcPr>
+                </a:tc>
+                <a:tc>
+                  <a:txBody>
+                    <a:bodyPr/>
+                    <a:lstStyle/>
+                    <a:p>
+                      <a:pPr algn="l"/>
+                      <a:r>
+                        <a:rPr sz="900" b="0">
+                          <a:solidFill>
+                            <a:srgbClr val="C8C8C8"/>
+                          </a:solidFill>
+                        </a:rPr>
+                        <a:t>No data</a:t>
+                      </a:r>
+                    </a:p>
+                  </a:txBody>
+                  <a:tcPr>
+                    <a:solidFill>
+                      <a:srgbClr val="F5F5F5"/>
+                    </a:solidFill>
+                  </a:tcPr>
+                </a:tc>
+                <a:tc>
+                  <a:txBody>
+                    <a:bodyPr/>
+                    <a:lstStyle/>
+                    <a:p>
+                      <a:pPr algn="l"/>
+                      <a:r>
+                        <a:rPr sz="900" b="0">
+                          <a:solidFill>
+                            <a:srgbClr val="C8C8C8"/>
+                          </a:solidFill>
+                        </a:rPr>
+                        <a:t>No data</a:t>
+                      </a:r>
+                    </a:p>
+                  </a:txBody>
+                  <a:tcPr>
+                    <a:solidFill>
+                      <a:srgbClr val="F5F5F5"/>
+                    </a:solidFill>
+                  </a:tcPr>
+                </a:tc>
+              </a:tr>
+              <a:tr h="685800">
+                <a:tc>
+                  <a:txBody>
+                    <a:bodyPr/>
+                    <a:lstStyle/>
+                    <a:p>
+                      <a:pPr algn="l"/>
+                      <a:r>
+                        <a:rPr sz="1100" b="1">
+                          <a:solidFill>
+                            <a:srgbClr val="000000"/>
+                          </a:solidFill>
+                        </a:rPr>
+                        <a:t>IIIa</a:t>
+                      </a:r>
+                    </a:p>
+                  </a:txBody>
+                  <a:tcPr>
+                    <a:solidFill>
+                      <a:srgbClr val="FFFFFF"/>
+                    </a:solidFill>
+                  </a:tcPr>
+                </a:tc>
+                <a:tc>
+                  <a:txBody>
+                    <a:bodyPr/>
+                    <a:lstStyle/>
+                    <a:p>
+                      <a:pPr algn="l"/>
+                      <a:r>
+                        <a:rPr sz="1000" b="0">
+                          <a:solidFill>
+                            <a:srgbClr val="000000"/>
+                          </a:solidFill>
+                        </a:rPr>
+                        <a:t>MI (4-class)</a:t>
+                      </a:r>
+                    </a:p>
+                  </a:txBody>
+                  <a:tcPr>
+                    <a:solidFill>
+                      <a:srgbClr val="F5F5F5"/>
+                    </a:solidFill>
+                  </a:tcPr>
+                </a:tc>
+                <a:tc>
+                  <a:txBody>
+                    <a:bodyPr/>
+                    <a:lstStyle/>
+                    <a:p>
+                      <a:pPr algn="l"/>
+                      <a:r>
+                        <a:rPr sz="900" b="0">
+                          <a:solidFill>
+                            <a:srgbClr val="C8C8C8"/>
+                          </a:solidFill>
+                        </a:rPr>
+                        <a:t>No data</a:t>
+                      </a:r>
+                    </a:p>
+                  </a:txBody>
+                  <a:tcPr>
+                    <a:solidFill>
+                      <a:srgbClr val="F5F5F5"/>
+                    </a:solidFill>
+                  </a:tcPr>
+                </a:tc>
+                <a:tc>
+                  <a:txBody>
+                    <a:bodyPr/>
+                    <a:lstStyle/>
+                    <a:p>
+                      <a:pPr algn="l"/>
+                      <a:r>
+                        <a:rPr sz="900" b="0">
+                          <a:solidFill>
+                            <a:srgbClr val="C8C8C8"/>
+                          </a:solidFill>
+                        </a:rPr>
+                        <a:t>No data</a:t>
+                      </a:r>
+                    </a:p>
+                  </a:txBody>
+                  <a:tcPr>
+                    <a:solidFill>
+                      <a:srgbClr val="F5F5F5"/>
+                    </a:solidFill>
+                  </a:tcPr>
+                </a:tc>
+                <a:tc>
+                  <a:txBody>
+                    <a:bodyPr/>
+                    <a:lstStyle/>
+                    <a:p>
+                      <a:pPr algn="l"/>
+                      <a:r>
+                        <a:rPr sz="900" b="0">
+                          <a:solidFill>
+                            <a:srgbClr val="C8C8C8"/>
+                          </a:solidFill>
+                        </a:rPr>
+                        <a:t>No data</a:t>
+                      </a:r>
+                    </a:p>
+                  </a:txBody>
+                  <a:tcPr>
+                    <a:solidFill>
+                      <a:srgbClr val="F5F5F5"/>
+                    </a:solidFill>
+                  </a:tcPr>
+                </a:tc>
+              </a:tr>
+              <a:tr h="685800">
+                <a:tc>
+                  <a:txBody>
+                    <a:bodyPr/>
+                    <a:lstStyle/>
+                    <a:p>
+                      <a:pPr algn="l"/>
+                      <a:r>
+                        <a:rPr sz="1100" b="1">
+                          <a:solidFill>
+                            <a:srgbClr val="000000"/>
+                          </a:solidFill>
+                        </a:rPr>
+                        <a:t>Physionet-MI</a:t>
+                      </a:r>
+                    </a:p>
+                  </a:txBody>
+                  <a:tcPr>
+                    <a:solidFill>
+                      <a:srgbClr val="FFFFFF"/>
+                    </a:solidFill>
+                  </a:tcPr>
+                </a:tc>
+                <a:tc>
+                  <a:txBody>
+                    <a:bodyPr/>
+                    <a:lstStyle/>
+                    <a:p>
+                      <a:pPr algn="l"/>
+                      <a:r>
+                        <a:rPr sz="1000" b="0">
+                          <a:solidFill>
+                            <a:srgbClr val="000000"/>
+                          </a:solidFill>
+                        </a:rPr>
+                        <a:t>MI (4-class)</a:t>
+                      </a:r>
+                    </a:p>
+                  </a:txBody>
+                  <a:tcPr>
+                    <a:solidFill>
+                      <a:srgbClr val="F5F5F5"/>
+                    </a:solidFill>
+                  </a:tcPr>
+                </a:tc>
+                <a:tc>
+                  <a:txBody>
+                    <a:bodyPr/>
+                    <a:lstStyle/>
+                    <a:p>
+                      <a:pPr algn="l"/>
+                      <a:r>
+                        <a:rPr sz="900" b="0">
+                          <a:solidFill>
+                            <a:srgbClr val="C8C8C8"/>
+                          </a:solidFill>
+                        </a:rPr>
+                        <a:t>No data</a:t>
+                      </a:r>
+                    </a:p>
+                  </a:txBody>
+                  <a:tcPr>
+                    <a:solidFill>
+                      <a:srgbClr val="F5F5F5"/>
+                    </a:solidFill>
+                  </a:tcPr>
+                </a:tc>
+                <a:tc>
+                  <a:txBody>
+                    <a:bodyPr/>
+                    <a:lstStyle/>
+                    <a:p>
+                      <a:pPr algn="l"/>
+                      <a:r>
+                        <a:rPr sz="900" b="0">
+                          <a:solidFill>
+                            <a:srgbClr val="C8C8C8"/>
+                          </a:solidFill>
+                        </a:rPr>
+                        <a:t>No data</a:t>
+                      </a:r>
+                    </a:p>
+                  </a:txBody>
+                  <a:tcPr>
+                    <a:solidFill>
+                      <a:srgbClr val="F5F5F5"/>
+                    </a:solidFill>
+                  </a:tcPr>
+                </a:tc>
+                <a:tc>
+                  <a:txBody>
+                    <a:bodyPr/>
+                    <a:lstStyle/>
+                    <a:p>
+                      <a:pPr algn="l"/>
+                      <a:r>
+                        <a:rPr sz="900" b="0">
+                          <a:solidFill>
+                            <a:srgbClr val="B48200"/>
+                          </a:solidFill>
+                        </a:rPr>
+                        <a:t>Ref: bAcc 0.6417
+Ours: bAcc 0.6181</a:t>
+                      </a:r>
+                    </a:p>
+                  </a:txBody>
+                  <a:tcPr>
+                    <a:solidFill>
+                      <a:srgbClr val="FFFADC"/>
+                    </a:solidFill>
+                  </a:tcPr>
+                </a:tc>
+              </a:tr>
+              <a:tr h="685800">
+                <a:tc>
+                  <a:txBody>
+                    <a:bodyPr/>
+                    <a:lstStyle/>
+                    <a:p>
+                      <a:pPr algn="l"/>
+                      <a:r>
+                        <a:rPr sz="1100" b="1">
+                          <a:solidFill>
+                            <a:srgbClr val="000000"/>
+                          </a:solidFill>
+                        </a:rPr>
+                        <a:t>FACED</a:t>
+                      </a:r>
+                    </a:p>
+                  </a:txBody>
+                  <a:tcPr>
+                    <a:solidFill>
+                      <a:srgbClr val="FFFFFF"/>
+                    </a:solidFill>
+                  </a:tcPr>
+                </a:tc>
+                <a:tc>
+                  <a:txBody>
+                    <a:bodyPr/>
+                    <a:lstStyle/>
+                    <a:p>
+                      <a:pPr algn="l"/>
+                      <a:r>
+                        <a:rPr sz="1000" b="0">
+                          <a:solidFill>
+                            <a:srgbClr val="000000"/>
+                          </a:solidFill>
+                        </a:rPr>
+                        <a:t>Emotion</a:t>
+                      </a:r>
+                    </a:p>
+                  </a:txBody>
+                  <a:tcPr>
+                    <a:solidFill>
+                      <a:srgbClr val="F5F5F5"/>
+                    </a:solidFill>
+                  </a:tcPr>
+                </a:tc>
+                <a:tc>
+                  <a:txBody>
+                    <a:bodyPr/>
+                    <a:lstStyle/>
+                    <a:p>
+                      <a:pPr algn="l"/>
+                      <a:r>
+                        <a:rPr sz="900" b="0">
+                          <a:solidFill>
+                            <a:srgbClr val="C8C8C8"/>
+                          </a:solidFill>
+                        </a:rPr>
+                        <a:t>No data</a:t>
+                      </a:r>
+                    </a:p>
+                  </a:txBody>
+                  <a:tcPr>
+                    <a:solidFill>
+                      <a:srgbClr val="F5F5F5"/>
+                    </a:solidFill>
+                  </a:tcPr>
+                </a:tc>
+                <a:tc>
+                  <a:txBody>
+                    <a:bodyPr/>
+                    <a:lstStyle/>
+                    <a:p>
+                      <a:pPr algn="l"/>
+                      <a:r>
+                        <a:rPr sz="900" b="0">
+                          <a:solidFill>
+                            <a:srgbClr val="C8C8C8"/>
+                          </a:solidFill>
+                        </a:rPr>
+                        <a:t>No data</a:t>
+                      </a:r>
+                    </a:p>
+                  </a:txBody>
+                  <a:tcPr>
+                    <a:solidFill>
+                      <a:srgbClr val="F5F5F5"/>
+                    </a:solidFill>
+                  </a:tcPr>
+                </a:tc>
+                <a:tc>
+                  <a:txBody>
+                    <a:bodyPr/>
+                    <a:lstStyle/>
+                    <a:p>
+                      <a:pPr algn="l"/>
+                      <a:r>
+                        <a:rPr sz="900" b="0">
+                          <a:solidFill>
+                            <a:srgbClr val="B48200"/>
+                          </a:solidFill>
+                        </a:rPr>
+                        <a:t>Ref: bAcc 0.5509
+Ours: bAcc 0.5340</a:t>
+                      </a:r>
+                    </a:p>
+                  </a:txBody>
+                  <a:tcPr>
+                    <a:solidFill>
+                      <a:srgbClr val="FFFADC"/>
+                    </a:solidFill>
+                  </a:tcPr>
+                </a:tc>
+              </a:tr>
+              <a:tr h="685800">
+                <a:tc>
+                  <a:txBody>
+                    <a:bodyPr/>
+                    <a:lstStyle/>
+                    <a:p>
+                      <a:pPr algn="l"/>
+                      <a:r>
+                        <a:rPr sz="1100" b="1">
+                          <a:solidFill>
+                            <a:srgbClr val="000000"/>
+                          </a:solidFill>
+                        </a:rPr>
+                        <a:t>ISRUC-S1</a:t>
+                      </a:r>
+                    </a:p>
+                  </a:txBody>
+                  <a:tcPr>
+                    <a:solidFill>
+                      <a:srgbClr val="FFFFFF"/>
+                    </a:solidFill>
+                  </a:tcPr>
+                </a:tc>
+                <a:tc>
+                  <a:txBody>
+                    <a:bodyPr/>
+                    <a:lstStyle/>
+                    <a:p>
+                      <a:pPr algn="l"/>
+                      <a:r>
+                        <a:rPr sz="1000" b="0">
+                          <a:solidFill>
+                            <a:srgbClr val="000000"/>
+                          </a:solidFill>
+                        </a:rPr>
+                        <a:t>Sleep Staging</a:t>
+                      </a:r>
+                    </a:p>
+                  </a:txBody>
+                  <a:tcPr>
+                    <a:solidFill>
+                      <a:srgbClr val="F5F5F5"/>
+                    </a:solidFill>
+                  </a:tcPr>
+                </a:tc>
+                <a:tc>
+                  <a:txBody>
+                    <a:bodyPr/>
+                    <a:lstStyle/>
+                    <a:p>
+                      <a:pPr algn="l"/>
+                      <a:r>
+                        <a:rPr sz="900" b="0">
+                          <a:solidFill>
+                            <a:srgbClr val="C8C8C8"/>
+                          </a:solidFill>
+                        </a:rPr>
+                        <a:t>No data</a:t>
+                      </a:r>
+                    </a:p>
+                  </a:txBody>
+                  <a:tcPr>
+                    <a:solidFill>
+                      <a:srgbClr val="F5F5F5"/>
+                    </a:solidFill>
+                  </a:tcPr>
+                </a:tc>
+                <a:tc>
+                  <a:txBody>
+                    <a:bodyPr/>
+                    <a:lstStyle/>
+                    <a:p>
+                      <a:pPr algn="l"/>
+                      <a:r>
+                        <a:rPr sz="900" b="0">
+                          <a:solidFill>
+                            <a:srgbClr val="C8C8C8"/>
+                          </a:solidFill>
+                        </a:rPr>
+                        <a:t>No data</a:t>
+                      </a:r>
+                    </a:p>
+                  </a:txBody>
+                  <a:tcPr>
+                    <a:solidFill>
+                      <a:srgbClr val="F5F5F5"/>
+                    </a:solidFill>
+                  </a:tcPr>
+                </a:tc>
+                <a:tc>
+                  <a:txBody>
+                    <a:bodyPr/>
+                    <a:lstStyle/>
+                    <a:p>
+                      <a:pPr algn="l"/>
+                      <a:r>
+                        <a:rPr sz="900" b="1">
+                          <a:solidFill>
+                            <a:srgbClr val="145A32"/>
+                          </a:solidFill>
+                        </a:rPr>
+                        <a:t>Ref: bAcc 0.7865
+Ours: bAcc 0.7850</a:t>
+                      </a:r>
+                    </a:p>
+                  </a:txBody>
+                  <a:tcPr>
+                    <a:solidFill>
+                      <a:srgbClr val="DCFFE6"/>
+                    </a:solidFill>
+                  </a:tcPr>
+                </a:tc>
+              </a:tr>
+              <a:tr h="685800">
+                <a:tc>
+                  <a:txBody>
+                    <a:bodyPr/>
+                    <a:lstStyle/>
+                    <a:p>
+                      <a:pPr algn="l"/>
+                      <a:r>
+                        <a:rPr sz="1100" b="1">
+                          <a:solidFill>
+                            <a:srgbClr val="000000"/>
+                          </a:solidFill>
+                        </a:rPr>
+                        <a:t>SEED-V</a:t>
+                      </a:r>
+                    </a:p>
+                  </a:txBody>
+                  <a:tcPr>
+                    <a:solidFill>
+                      <a:srgbClr val="FFFFFF"/>
+                    </a:solidFill>
+                  </a:tcPr>
+                </a:tc>
+                <a:tc>
+                  <a:txBody>
+                    <a:bodyPr/>
+                    <a:lstStyle/>
+                    <a:p>
+                      <a:pPr algn="l"/>
+                      <a:r>
+                        <a:rPr sz="1000" b="0">
+                          <a:solidFill>
+                            <a:srgbClr val="000000"/>
+                          </a:solidFill>
+                        </a:rPr>
+                        <a:t>Emotion</a:t>
+                      </a:r>
+                    </a:p>
+                  </a:txBody>
+                  <a:tcPr>
+                    <a:solidFill>
+                      <a:srgbClr val="F5F5F5"/>
+                    </a:solidFill>
+                  </a:tcPr>
+                </a:tc>
+                <a:tc>
+                  <a:txBody>
+                    <a:bodyPr/>
+                    <a:lstStyle/>
+                    <a:p>
+                      <a:pPr algn="l"/>
+                      <a:r>
+                        <a:rPr sz="900" b="0">
+                          <a:solidFill>
+                            <a:srgbClr val="C8C8C8"/>
+                          </a:solidFill>
+                        </a:rPr>
+                        <a:t>No data</a:t>
+                      </a:r>
+                    </a:p>
+                  </a:txBody>
+                  <a:tcPr>
+                    <a:solidFill>
+                      <a:srgbClr val="F5F5F5"/>
+                    </a:solidFill>
+                  </a:tcPr>
+                </a:tc>
+                <a:tc>
+                  <a:txBody>
+                    <a:bodyPr/>
+                    <a:lstStyle/>
+                    <a:p>
+                      <a:pPr algn="l"/>
+                      <a:r>
+                        <a:rPr sz="900" b="0">
+                          <a:solidFill>
+                            <a:srgbClr val="C8C8C8"/>
+                          </a:solidFill>
+                        </a:rPr>
+                        <a:t>No data</a:t>
+                      </a:r>
+                    </a:p>
+                  </a:txBody>
+                  <a:tcPr>
+                    <a:solidFill>
+                      <a:srgbClr val="F5F5F5"/>
+                    </a:solidFill>
+                  </a:tcPr>
+                </a:tc>
+                <a:tc>
+                  <a:txBody>
+                    <a:bodyPr/>
+                    <a:lstStyle/>
+                    <a:p>
+                      <a:pPr algn="l"/>
+                      <a:r>
+                        <a:rPr sz="900" b="0">
+                          <a:solidFill>
+                            <a:srgbClr val="B48200"/>
+                          </a:solidFill>
+                        </a:rPr>
+                        <a:t>Ref: bAcc 0.4091
+Ours: bAcc 0.4018</a:t>
+                      </a:r>
+                    </a:p>
+                  </a:txBody>
+                  <a:tcPr>
+                    <a:solidFill>
+                      <a:srgbClr val="FFFADC"/>
+                    </a:solidFill>
+                  </a:tcPr>
+                </a:tc>
+              </a:tr>
+              <a:tr h="685800">
+                <a:tc>
+                  <a:txBody>
+                    <a:bodyPr/>
+                    <a:lstStyle/>
+                    <a:p>
+                      <a:pPr algn="l"/>
+                      <a:r>
+                        <a:rPr sz="1100" b="1">
+                          <a:solidFill>
+                            <a:srgbClr val="000000"/>
+                          </a:solidFill>
+                        </a:rPr>
+                        <a:t>SHU-MI</a:t>
+                      </a:r>
+                    </a:p>
+                  </a:txBody>
+                  <a:tcPr>
+                    <a:solidFill>
+                      <a:srgbClr val="FFFFFF"/>
+                    </a:solidFill>
+                  </a:tcPr>
+                </a:tc>
+                <a:tc>
+                  <a:txBody>
+                    <a:bodyPr/>
+                    <a:lstStyle/>
+                    <a:p>
+                      <a:pPr algn="l"/>
+                      <a:r>
+                        <a:rPr sz="1000" b="0">
+                          <a:solidFill>
+                            <a:srgbClr val="000000"/>
+                          </a:solidFill>
+                        </a:rPr>
+                        <a:t>MI (4-class)</a:t>
+                      </a:r>
+                    </a:p>
+                  </a:txBody>
+                  <a:tcPr>
+                    <a:solidFill>
+                      <a:srgbClr val="F5F5F5"/>
+                    </a:solidFill>
+                  </a:tcPr>
+                </a:tc>
+                <a:tc>
+                  <a:txBody>
+                    <a:bodyPr/>
+                    <a:lstStyle/>
+                    <a:p>
+                      <a:pPr algn="l"/>
+                      <a:r>
+                        <a:rPr sz="900" b="0">
+                          <a:solidFill>
+                            <a:srgbClr val="C8C8C8"/>
+                          </a:solidFill>
+                        </a:rPr>
+                        <a:t>No data</a:t>
+                      </a:r>
+                    </a:p>
+                  </a:txBody>
+                  <a:tcPr>
+                    <a:solidFill>
+                      <a:srgbClr val="F5F5F5"/>
+                    </a:solidFill>
+                  </a:tcPr>
+                </a:tc>
+                <a:tc>
+                  <a:txBody>
+                    <a:bodyPr/>
+                    <a:lstStyle/>
+                    <a:p>
+                      <a:pPr algn="l"/>
+                      <a:r>
+                        <a:rPr sz="900" b="0">
+                          <a:solidFill>
+                            <a:srgbClr val="C8C8C8"/>
+                          </a:solidFill>
+                        </a:rPr>
+                        <a:t>No data</a:t>
+                      </a:r>
+                    </a:p>
+                  </a:txBody>
+                  <a:tcPr>
+                    <a:solidFill>
+                      <a:srgbClr val="F5F5F5"/>
+                    </a:solidFill>
+                  </a:tcPr>
+                </a:tc>
+                <a:tc>
+                  <a:txBody>
+                    <a:bodyPr/>
+                    <a:lstStyle/>
+                    <a:p>
+                      <a:pPr algn="l"/>
+                      <a:r>
+                        <a:rPr sz="900" b="1">
+                          <a:solidFill>
+                            <a:srgbClr val="145A32"/>
+                          </a:solidFill>
+                        </a:rPr>
+                        <a:t>Ref: bAcc 0.6370
+Ours: bAcc 0.6380</a:t>
+                      </a:r>
+                    </a:p>
+                  </a:txBody>
+                  <a:tcPr>
+                    <a:solidFill>
+                      <a:srgbClr val="DCFFE6"/>
+                    </a:solidFill>
+                  </a:tcPr>
+                </a:tc>
+              </a:tr>
+              <a:tr h="685800">
+                <a:tc>
+                  <a:txBody>
+                    <a:bodyPr/>
+                    <a:lstStyle/>
+                    <a:p>
+                      <a:pPr algn="l"/>
+                      <a:r>
+                        <a:rPr sz="1100" b="1">
+                          <a:solidFill>
+                            <a:srgbClr val="000000"/>
+                          </a:solidFill>
+                        </a:rPr>
+                        <a:t>MDD</a:t>
+                      </a:r>
+                    </a:p>
+                  </a:txBody>
+                  <a:tcPr>
+                    <a:solidFill>
+                      <a:srgbClr val="FFFFFF"/>
+                    </a:solidFill>
+                  </a:tcPr>
+                </a:tc>
+                <a:tc>
+                  <a:txBody>
+                    <a:bodyPr/>
+                    <a:lstStyle/>
+                    <a:p>
+                      <a:pPr algn="l"/>
+                      <a:r>
+                        <a:rPr sz="1000" b="0">
+                          <a:solidFill>
+                            <a:srgbClr val="000000"/>
+                          </a:solidFill>
+                        </a:rPr>
+                        <a:t>Clinical (depression)</a:t>
+                      </a:r>
+                    </a:p>
+                  </a:txBody>
+                  <a:tcPr>
+                    <a:solidFill>
+                      <a:srgbClr val="F5F5F5"/>
+                    </a:solidFill>
+                  </a:tcPr>
+                </a:tc>
+                <a:tc>
+                  <a:txBody>
+                    <a:bodyPr/>
+                    <a:lstStyle/>
+                    <a:p>
+                      <a:pPr algn="l"/>
+                      <a:r>
+                        <a:rPr sz="900" b="0">
+                          <a:solidFill>
+                            <a:srgbClr val="C8C8C8"/>
+                          </a:solidFill>
+                        </a:rPr>
+                        <a:t>No data</a:t>
+                      </a:r>
+                    </a:p>
+                  </a:txBody>
+                  <a:tcPr>
+                    <a:solidFill>
+                      <a:srgbClr val="F5F5F5"/>
+                    </a:solidFill>
+                  </a:tcPr>
+                </a:tc>
+                <a:tc>
+                  <a:txBody>
+                    <a:bodyPr/>
+                    <a:lstStyle/>
+                    <a:p>
+                      <a:pPr algn="l"/>
+                      <a:r>
+                        <a:rPr sz="900" b="0">
+                          <a:solidFill>
+                            <a:srgbClr val="C8C8C8"/>
+                          </a:solidFill>
+                        </a:rPr>
+                        <a:t>No data</a:t>
+                      </a:r>
+                    </a:p>
+                  </a:txBody>
+                  <a:tcPr>
+                    <a:solidFill>
+                      <a:srgbClr val="F5F5F5"/>
+                    </a:solidFill>
+                  </a:tcPr>
+                </a:tc>
+                <a:tc>
+                  <a:txBody>
+                    <a:bodyPr/>
+                    <a:lstStyle/>
+                    <a:p>
+                      <a:pPr algn="l"/>
+                      <a:r>
+                        <a:rPr sz="900" b="1">
+                          <a:solidFill>
+                            <a:srgbClr val="145A32"/>
+                          </a:solidFill>
+                        </a:rPr>
+                        <a:t>Ref: bAcc 0.9560
+Ours: bAcc 0.9674</a:t>
+                      </a:r>
+                    </a:p>
+                  </a:txBody>
+                  <a:tcPr>
+                    <a:solidFill>
+                      <a:srgbClr val="DCFFE6"/>
+                    </a:solidFill>
+                  </a:tcPr>
+                </a:tc>
+              </a:tr>
+              <a:tr h="685800">
+                <a:tc>
+                  <a:txBody>
+                    <a:bodyPr/>
+                    <a:lstStyle/>
+                    <a:p>
+                      <a:pPr algn="l"/>
+                      <a:r>
+                        <a:rPr sz="1100" b="1">
+                          <a:solidFill>
+                            <a:srgbClr val="000000"/>
+                          </a:solidFill>
+                        </a:rPr>
+                        <a:t>TUEV</a:t>
+                      </a:r>
+                    </a:p>
+                  </a:txBody>
+                  <a:tcPr>
+                    <a:solidFill>
+                      <a:srgbClr val="FFFFFF"/>
+                    </a:solidFill>
+                  </a:tcPr>
+                </a:tc>
+                <a:tc>
+                  <a:txBody>
+                    <a:bodyPr/>
+                    <a:lstStyle/>
+                    <a:p>
+                      <a:pPr algn="l"/>
+                      <a:r>
+                        <a:rPr sz="1000" b="0">
+                          <a:solidFill>
+                            <a:srgbClr val="000000"/>
+                          </a:solidFill>
+                        </a:rPr>
+                        <a:t>Pathology</a:t>
+                      </a:r>
+                    </a:p>
+                  </a:txBody>
+                  <a:tcPr>
+                    <a:solidFill>
+                      <a:srgbClr val="F5F5F5"/>
+                    </a:solidFill>
+                  </a:tcPr>
+                </a:tc>
+                <a:tc>
+                  <a:txBody>
+                    <a:bodyPr/>
+                    <a:lstStyle/>
+                    <a:p>
+                      <a:pPr algn="l"/>
+                      <a:r>
+                        <a:rPr sz="900" b="0">
+                          <a:solidFill>
+                            <a:srgbClr val="C8C8C8"/>
+                          </a:solidFill>
+                        </a:rPr>
+                        <a:t>No data</a:t>
+                      </a:r>
+                    </a:p>
+                  </a:txBody>
+                  <a:tcPr>
+                    <a:solidFill>
+                      <a:srgbClr val="F5F5F5"/>
+                    </a:solidFill>
+                  </a:tcPr>
+                </a:tc>
+                <a:tc>
+                  <a:txBody>
+                    <a:bodyPr/>
+                    <a:lstStyle/>
+                    <a:p>
+                      <a:pPr algn="l"/>
+                      <a:r>
+                        <a:rPr sz="900" b="0">
+                          <a:solidFill>
+                            <a:srgbClr val="C8C8C8"/>
+                          </a:solidFill>
+                        </a:rPr>
+                        <a:t>No data</a:t>
+                      </a:r>
+                    </a:p>
+                  </a:txBody>
+                  <a:tcPr>
+                    <a:solidFill>
+                      <a:srgbClr val="F5F5F5"/>
+                    </a:solidFill>
+                  </a:tcPr>
+                </a:tc>
+                <a:tc>
+                  <a:txBody>
+                    <a:bodyPr/>
+                    <a:lstStyle/>
+                    <a:p>
+                      <a:pPr algn="l"/>
+                      <a:r>
+                        <a:rPr sz="900" b="1">
+                          <a:solidFill>
+                            <a:srgbClr val="E74C3C"/>
+                          </a:solidFill>
+                        </a:rPr>
+                        <a:t>Ref: k 0.6671
+Ours: k 0.6343</a:t>
+                      </a:r>
+                    </a:p>
+                  </a:txBody>
+                  <a:tcPr>
+                    <a:solidFill>
+                      <a:srgbClr val="FFE6E6"/>
+                    </a:solidFill>
+                  </a:tcPr>
+                </a:tc>
+              </a:tr>
+              <a:tr h="685800">
+                <a:tc>
+                  <a:txBody>
+                    <a:bodyPr/>
+                    <a:lstStyle/>
+                    <a:p>
+                      <a:pPr algn="ctr"/>
+                      <a:r>
+                        <a:rPr sz="1100" b="1">
+                          <a:solidFill>
+                            <a:srgbClr val="FFFFFF"/>
+                          </a:solidFill>
+                        </a:rPr>
+                        <a:t>Summary</a:t>
+                      </a:r>
+                    </a:p>
+                  </a:txBody>
+                  <a:tcPr>
+                    <a:solidFill>
+                      <a:srgbClr val="3C3C3C"/>
+                    </a:solidFill>
+                  </a:tcPr>
+                </a:tc>
+                <a:tc>
+                  <a:txBody>
+                    <a:bodyPr/>
+                    <a:lstStyle/>
+                    <a:p>
+                      <a:pPr algn="ctr"/>
+                      <a:r>
+                        <a:rPr sz="1100" b="0">
+                          <a:solidFill>
+                            <a:srgbClr val="000000"/>
+                          </a:solidFill>
+                        </a:rPr>
+                        <a:t/>
+                      </a:r>
+                    </a:p>
+                  </a:txBody>
+                  <a:tcPr>
+                    <a:solidFill>
+                      <a:srgbClr val="3C3C3C"/>
+                    </a:solidFill>
+                  </a:tcPr>
+                </a:tc>
+                <a:tc>
+                  <a:txBody>
+                    <a:bodyPr/>
+                    <a:lstStyle/>
+                    <a:p>
                       <a:pPr algn="ctr"/>
                       <a:r>
                         <a:rPr sz="1000" b="1">
                           <a:solidFill>
+                            <a:srgbClr val="F1C40F"/>
+                          </a:solidFill>
+                        </a:rPr>
+                        <a:t>Y:2  No data:8</a:t>
+                      </a:r>
+                    </a:p>
+                  </a:txBody>
+                  <a:tcPr>
+                    <a:solidFill>
+                      <a:srgbClr val="FFFADC"/>
+                    </a:solidFill>
+                  </a:tcPr>
+                </a:tc>
+                <a:tc>
+                  <a:txBody>
+                    <a:bodyPr/>
+                    <a:lstStyle/>
+                    <a:p>
+                      <a:pPr algn="ctr"/>
+                      <a:r>
+                        <a:rPr sz="1000" b="1">
+                          <a:solidFill>
                             <a:srgbClr val="27AE60"/>
                           </a:solidFill>
                         </a:rPr>
-                        <a:t>79.17% val</a:t>
+                        <a:t>G:1  No data:9</a:t>
                       </a:r>
                     </a:p>
                   </a:txBody>
@@ -8686,1043 +9813,13 @@
                             <a:srgbClr val="27AE60"/>
                           </a:solidFill>
                         </a:rPr>
-                        <a:t>78.66% avg</a:t>
+                        <a:t>G:4  Y:3  R:1  No data:2</a:t>
                       </a:r>
                     </a:p>
                   </a:txBody>
                   <a:tcPr>
                     <a:solidFill>
                       <a:srgbClr val="DCFFE6"/>
-                    </a:solidFill>
-                  </a:tcPr>
-                </a:tc>
-                <a:tc>
-                  <a:txBody>
-                    <a:bodyPr/>
-                    <a:lstStyle/>
-                    <a:p>
-                      <a:pPr algn="ctr"/>
-                      <a:r>
-                        <a:rPr sz="1000" b="1">
-                          <a:solidFill>
-                            <a:srgbClr val="27AE60"/>
-                          </a:solidFill>
-                        </a:rPr>
-                        <a:t>bAcc 0.671</a:t>
-                      </a:r>
-                    </a:p>
-                  </a:txBody>
-                  <a:tcPr>
-                    <a:solidFill>
-                      <a:srgbClr val="DCFFE6"/>
-                    </a:solidFill>
-                  </a:tcPr>
-                </a:tc>
-              </a:tr>
-              <a:tr h="502920">
-                <a:tc>
-                  <a:txBody>
-                    <a:bodyPr/>
-                    <a:lstStyle/>
-                    <a:p>
-                      <a:pPr algn="l"/>
-                      <a:r>
-                        <a:rPr sz="1100" b="1">
-                          <a:solidFill>
-                            <a:srgbClr val="000000"/>
-                          </a:solidFill>
-                        </a:rPr>
-                        <a:t>BCICIV2B</a:t>
-                      </a:r>
-                    </a:p>
-                  </a:txBody>
-                  <a:tcPr>
-                    <a:solidFill>
-                      <a:srgbClr val="FFFFFF"/>
-                    </a:solidFill>
-                  </a:tcPr>
-                </a:tc>
-                <a:tc>
-                  <a:txBody>
-                    <a:bodyPr/>
-                    <a:lstStyle/>
-                    <a:p>
-                      <a:pPr algn="l"/>
-                      <a:r>
-                        <a:rPr sz="1000" b="0">
-                          <a:solidFill>
-                            <a:srgbClr val="000000"/>
-                          </a:solidFill>
-                        </a:rPr>
-                        <a:t>Motor Imagery</a:t>
-                      </a:r>
-                    </a:p>
-                  </a:txBody>
-                  <a:tcPr>
-                    <a:solidFill>
-                      <a:srgbClr val="F5F5F5"/>
-                    </a:solidFill>
-                  </a:tcPr>
-                </a:tc>
-                <a:tc>
-                  <a:txBody>
-                    <a:bodyPr/>
-                    <a:lstStyle/>
-                    <a:p>
-                      <a:pPr algn="ctr"/>
-                      <a:r>
-                        <a:rPr sz="1000" b="1">
-                          <a:solidFill>
-                            <a:srgbClr val="27AE60"/>
-                          </a:solidFill>
-                        </a:rPr>
-                        <a:t>78.35%, k=0.57</a:t>
-                      </a:r>
-                    </a:p>
-                  </a:txBody>
-                  <a:tcPr>
-                    <a:solidFill>
-                      <a:srgbClr val="DCFFE6"/>
-                    </a:solidFill>
-                  </a:tcPr>
-                </a:tc>
-                <a:tc>
-                  <a:txBody>
-                    <a:bodyPr/>
-                    <a:lstStyle/>
-                    <a:p>
-                      <a:pPr algn="ctr"/>
-                      <a:r>
-                        <a:rPr sz="1000" b="0">
-                          <a:solidFill>
-                            <a:srgbClr val="C8C8C8"/>
-                          </a:solidFill>
-                        </a:rPr>
-                        <a:t>--</a:t>
-                      </a:r>
-                    </a:p>
-                  </a:txBody>
-                  <a:tcPr>
-                    <a:solidFill>
-                      <a:srgbClr val="F5F5F5"/>
-                    </a:solidFill>
-                  </a:tcPr>
-                </a:tc>
-                <a:tc>
-                  <a:txBody>
-                    <a:bodyPr/>
-                    <a:lstStyle/>
-                    <a:p>
-                      <a:pPr algn="ctr"/>
-                      <a:r>
-                        <a:rPr sz="1000" b="0">
-                          <a:solidFill>
-                            <a:srgbClr val="C8C8C8"/>
-                          </a:solidFill>
-                        </a:rPr>
-                        <a:t>--</a:t>
-                      </a:r>
-                    </a:p>
-                  </a:txBody>
-                  <a:tcPr>
-                    <a:solidFill>
-                      <a:srgbClr val="F5F5F5"/>
-                    </a:solidFill>
-                  </a:tcPr>
-                </a:tc>
-              </a:tr>
-              <a:tr h="502920">
-                <a:tc>
-                  <a:txBody>
-                    <a:bodyPr/>
-                    <a:lstStyle/>
-                    <a:p>
-                      <a:pPr algn="l"/>
-                      <a:r>
-                        <a:rPr sz="1100" b="1">
-                          <a:solidFill>
-                            <a:srgbClr val="000000"/>
-                          </a:solidFill>
-                        </a:rPr>
-                        <a:t>IIIa</a:t>
-                      </a:r>
-                    </a:p>
-                  </a:txBody>
-                  <a:tcPr>
-                    <a:solidFill>
-                      <a:srgbClr val="FFFFFF"/>
-                    </a:solidFill>
-                  </a:tcPr>
-                </a:tc>
-                <a:tc>
-                  <a:txBody>
-                    <a:bodyPr/>
-                    <a:lstStyle/>
-                    <a:p>
-                      <a:pPr algn="l"/>
-                      <a:r>
-                        <a:rPr sz="1000" b="0">
-                          <a:solidFill>
-                            <a:srgbClr val="000000"/>
-                          </a:solidFill>
-                        </a:rPr>
-                        <a:t>Motor Imagery</a:t>
-                      </a:r>
-                    </a:p>
-                  </a:txBody>
-                  <a:tcPr>
-                    <a:solidFill>
-                      <a:srgbClr val="F5F5F5"/>
-                    </a:solidFill>
-                  </a:tcPr>
-                </a:tc>
-                <a:tc>
-                  <a:txBody>
-                    <a:bodyPr/>
-                    <a:lstStyle/>
-                    <a:p>
-                      <a:pPr algn="ctr"/>
-                      <a:r>
-                        <a:rPr sz="1000" b="1">
-                          <a:solidFill>
-                            <a:srgbClr val="F1C40F"/>
-                          </a:solidFill>
-                        </a:rPr>
-                        <a:t>55.95% val</a:t>
-                      </a:r>
-                    </a:p>
-                  </a:txBody>
-                  <a:tcPr>
-                    <a:solidFill>
-                      <a:srgbClr val="FFFADC"/>
-                    </a:solidFill>
-                  </a:tcPr>
-                </a:tc>
-                <a:tc>
-                  <a:txBody>
-                    <a:bodyPr/>
-                    <a:lstStyle/>
-                    <a:p>
-                      <a:pPr algn="ctr"/>
-                      <a:r>
-                        <a:rPr sz="1000" b="0">
-                          <a:solidFill>
-                            <a:srgbClr val="C8C8C8"/>
-                          </a:solidFill>
-                        </a:rPr>
-                        <a:t>--</a:t>
-                      </a:r>
-                    </a:p>
-                  </a:txBody>
-                  <a:tcPr>
-                    <a:solidFill>
-                      <a:srgbClr val="F5F5F5"/>
-                    </a:solidFill>
-                  </a:tcPr>
-                </a:tc>
-                <a:tc>
-                  <a:txBody>
-                    <a:bodyPr/>
-                    <a:lstStyle/>
-                    <a:p>
-                      <a:pPr algn="ctr"/>
-                      <a:r>
-                        <a:rPr sz="1000" b="0">
-                          <a:solidFill>
-                            <a:srgbClr val="C8C8C8"/>
-                          </a:solidFill>
-                        </a:rPr>
-                        <a:t>--</a:t>
-                      </a:r>
-                    </a:p>
-                  </a:txBody>
-                  <a:tcPr>
-                    <a:solidFill>
-                      <a:srgbClr val="F5F5F5"/>
-                    </a:solidFill>
-                  </a:tcPr>
-                </a:tc>
-              </a:tr>
-              <a:tr h="502920">
-                <a:tc>
-                  <a:txBody>
-                    <a:bodyPr/>
-                    <a:lstStyle/>
-                    <a:p>
-                      <a:pPr algn="l"/>
-                      <a:r>
-                        <a:rPr sz="1100" b="1">
-                          <a:solidFill>
-                            <a:srgbClr val="000000"/>
-                          </a:solidFill>
-                        </a:rPr>
-                        <a:t>Physionet-MI</a:t>
-                      </a:r>
-                    </a:p>
-                  </a:txBody>
-                  <a:tcPr>
-                    <a:solidFill>
-                      <a:srgbClr val="FFFFFF"/>
-                    </a:solidFill>
-                  </a:tcPr>
-                </a:tc>
-                <a:tc>
-                  <a:txBody>
-                    <a:bodyPr/>
-                    <a:lstStyle/>
-                    <a:p>
-                      <a:pPr algn="l"/>
-                      <a:r>
-                        <a:rPr sz="1000" b="0">
-                          <a:solidFill>
-                            <a:srgbClr val="000000"/>
-                          </a:solidFill>
-                        </a:rPr>
-                        <a:t>Motor Imagery</a:t>
-                      </a:r>
-                    </a:p>
-                  </a:txBody>
-                  <a:tcPr>
-                    <a:solidFill>
-                      <a:srgbClr val="F5F5F5"/>
-                    </a:solidFill>
-                  </a:tcPr>
-                </a:tc>
-                <a:tc>
-                  <a:txBody>
-                    <a:bodyPr/>
-                    <a:lstStyle/>
-                    <a:p>
-                      <a:pPr algn="ctr"/>
-                      <a:r>
-                        <a:rPr sz="1000" b="1">
-                          <a:solidFill>
-                            <a:srgbClr val="F1C40F"/>
-                          </a:solidFill>
-                        </a:rPr>
-                        <a:t>49.30% val</a:t>
-                      </a:r>
-                    </a:p>
-                  </a:txBody>
-                  <a:tcPr>
-                    <a:solidFill>
-                      <a:srgbClr val="FFFADC"/>
-                    </a:solidFill>
-                  </a:tcPr>
-                </a:tc>
-                <a:tc>
-                  <a:txBody>
-                    <a:bodyPr/>
-                    <a:lstStyle/>
-                    <a:p>
-                      <a:pPr algn="ctr"/>
-                      <a:r>
-                        <a:rPr sz="1000" b="0">
-                          <a:solidFill>
-                            <a:srgbClr val="C8C8C8"/>
-                          </a:solidFill>
-                        </a:rPr>
-                        <a:t>--</a:t>
-                      </a:r>
-                    </a:p>
-                  </a:txBody>
-                  <a:tcPr>
-                    <a:solidFill>
-                      <a:srgbClr val="F5F5F5"/>
-                    </a:solidFill>
-                  </a:tcPr>
-                </a:tc>
-                <a:tc>
-                  <a:txBody>
-                    <a:bodyPr/>
-                    <a:lstStyle/>
-                    <a:p>
-                      <a:pPr algn="ctr"/>
-                      <a:r>
-                        <a:rPr sz="1000" b="1">
-                          <a:solidFill>
-                            <a:srgbClr val="F1C40F"/>
-                          </a:solidFill>
-                        </a:rPr>
-                        <a:t>bAcc 0.618</a:t>
-                      </a:r>
-                    </a:p>
-                  </a:txBody>
-                  <a:tcPr>
-                    <a:solidFill>
-                      <a:srgbClr val="FFFADC"/>
-                    </a:solidFill>
-                  </a:tcPr>
-                </a:tc>
-              </a:tr>
-              <a:tr h="502920">
-                <a:tc>
-                  <a:txBody>
-                    <a:bodyPr/>
-                    <a:lstStyle/>
-                    <a:p>
-                      <a:pPr algn="l"/>
-                      <a:r>
-                        <a:rPr sz="1100" b="1">
-                          <a:solidFill>
-                            <a:srgbClr val="000000"/>
-                          </a:solidFill>
-                        </a:rPr>
-                        <a:t>FACED</a:t>
-                      </a:r>
-                    </a:p>
-                  </a:txBody>
-                  <a:tcPr>
-                    <a:solidFill>
-                      <a:srgbClr val="FFFFFF"/>
-                    </a:solidFill>
-                  </a:tcPr>
-                </a:tc>
-                <a:tc>
-                  <a:txBody>
-                    <a:bodyPr/>
-                    <a:lstStyle/>
-                    <a:p>
-                      <a:pPr algn="l"/>
-                      <a:r>
-                        <a:rPr sz="1000" b="0">
-                          <a:solidFill>
-                            <a:srgbClr val="000000"/>
-                          </a:solidFill>
-                        </a:rPr>
-                        <a:t>Emotion</a:t>
-                      </a:r>
-                    </a:p>
-                  </a:txBody>
-                  <a:tcPr>
-                    <a:solidFill>
-                      <a:srgbClr val="F5F5F5"/>
-                    </a:solidFill>
-                  </a:tcPr>
-                </a:tc>
-                <a:tc>
-                  <a:txBody>
-                    <a:bodyPr/>
-                    <a:lstStyle/>
-                    <a:p>
-                      <a:pPr algn="ctr"/>
-                      <a:r>
-                        <a:rPr sz="1000" b="0">
-                          <a:solidFill>
-                            <a:srgbClr val="C8C8C8"/>
-                          </a:solidFill>
-                        </a:rPr>
-                        <a:t>--</a:t>
-                      </a:r>
-                    </a:p>
-                  </a:txBody>
-                  <a:tcPr>
-                    <a:solidFill>
-                      <a:srgbClr val="F5F5F5"/>
-                    </a:solidFill>
-                  </a:tcPr>
-                </a:tc>
-                <a:tc>
-                  <a:txBody>
-                    <a:bodyPr/>
-                    <a:lstStyle/>
-                    <a:p>
-                      <a:pPr algn="ctr"/>
-                      <a:r>
-                        <a:rPr sz="1000" b="0">
-                          <a:solidFill>
-                            <a:srgbClr val="C8C8C8"/>
-                          </a:solidFill>
-                        </a:rPr>
-                        <a:t>--</a:t>
-                      </a:r>
-                    </a:p>
-                  </a:txBody>
-                  <a:tcPr>
-                    <a:solidFill>
-                      <a:srgbClr val="F5F5F5"/>
-                    </a:solidFill>
-                  </a:tcPr>
-                </a:tc>
-                <a:tc>
-                  <a:txBody>
-                    <a:bodyPr/>
-                    <a:lstStyle/>
-                    <a:p>
-                      <a:pPr algn="ctr"/>
-                      <a:r>
-                        <a:rPr sz="1000" b="1">
-                          <a:solidFill>
-                            <a:srgbClr val="F1C40F"/>
-                          </a:solidFill>
-                        </a:rPr>
-                        <a:t>bAcc 0.534</a:t>
-                      </a:r>
-                    </a:p>
-                  </a:txBody>
-                  <a:tcPr>
-                    <a:solidFill>
-                      <a:srgbClr val="FFFADC"/>
-                    </a:solidFill>
-                  </a:tcPr>
-                </a:tc>
-              </a:tr>
-              <a:tr h="502920">
-                <a:tc>
-                  <a:txBody>
-                    <a:bodyPr/>
-                    <a:lstStyle/>
-                    <a:p>
-                      <a:pPr algn="l"/>
-                      <a:r>
-                        <a:rPr sz="1100" b="1">
-                          <a:solidFill>
-                            <a:srgbClr val="000000"/>
-                          </a:solidFill>
-                        </a:rPr>
-                        <a:t>ISRUC-S1</a:t>
-                      </a:r>
-                    </a:p>
-                  </a:txBody>
-                  <a:tcPr>
-                    <a:solidFill>
-                      <a:srgbClr val="FFFFFF"/>
-                    </a:solidFill>
-                  </a:tcPr>
-                </a:tc>
-                <a:tc>
-                  <a:txBody>
-                    <a:bodyPr/>
-                    <a:lstStyle/>
-                    <a:p>
-                      <a:pPr algn="l"/>
-                      <a:r>
-                        <a:rPr sz="1000" b="0">
-                          <a:solidFill>
-                            <a:srgbClr val="000000"/>
-                          </a:solidFill>
-                        </a:rPr>
-                        <a:t>Sleep Staging</a:t>
-                      </a:r>
-                    </a:p>
-                  </a:txBody>
-                  <a:tcPr>
-                    <a:solidFill>
-                      <a:srgbClr val="F5F5F5"/>
-                    </a:solidFill>
-                  </a:tcPr>
-                </a:tc>
-                <a:tc>
-                  <a:txBody>
-                    <a:bodyPr/>
-                    <a:lstStyle/>
-                    <a:p>
-                      <a:pPr algn="ctr"/>
-                      <a:r>
-                        <a:rPr sz="1000" b="0">
-                          <a:solidFill>
-                            <a:srgbClr val="C8C8C8"/>
-                          </a:solidFill>
-                        </a:rPr>
-                        <a:t>--</a:t>
-                      </a:r>
-                    </a:p>
-                  </a:txBody>
-                  <a:tcPr>
-                    <a:solidFill>
-                      <a:srgbClr val="F5F5F5"/>
-                    </a:solidFill>
-                  </a:tcPr>
-                </a:tc>
-                <a:tc>
-                  <a:txBody>
-                    <a:bodyPr/>
-                    <a:lstStyle/>
-                    <a:p>
-                      <a:pPr algn="ctr"/>
-                      <a:r>
-                        <a:rPr sz="1000" b="0">
-                          <a:solidFill>
-                            <a:srgbClr val="C8C8C8"/>
-                          </a:solidFill>
-                        </a:rPr>
-                        <a:t>--</a:t>
-                      </a:r>
-                    </a:p>
-                  </a:txBody>
-                  <a:tcPr>
-                    <a:solidFill>
-                      <a:srgbClr val="F5F5F5"/>
-                    </a:solidFill>
-                  </a:tcPr>
-                </a:tc>
-                <a:tc>
-                  <a:txBody>
-                    <a:bodyPr/>
-                    <a:lstStyle/>
-                    <a:p>
-                      <a:pPr algn="ctr"/>
-                      <a:r>
-                        <a:rPr sz="1000" b="1">
-                          <a:solidFill>
-                            <a:srgbClr val="27AE60"/>
-                          </a:solidFill>
-                        </a:rPr>
-                        <a:t>bAcc 0.785</a:t>
-                      </a:r>
-                    </a:p>
-                  </a:txBody>
-                  <a:tcPr>
-                    <a:solidFill>
-                      <a:srgbClr val="DCFFE6"/>
-                    </a:solidFill>
-                  </a:tcPr>
-                </a:tc>
-              </a:tr>
-              <a:tr h="502920">
-                <a:tc>
-                  <a:txBody>
-                    <a:bodyPr/>
-                    <a:lstStyle/>
-                    <a:p>
-                      <a:pPr algn="l"/>
-                      <a:r>
-                        <a:rPr sz="1100" b="1">
-                          <a:solidFill>
-                            <a:srgbClr val="000000"/>
-                          </a:solidFill>
-                        </a:rPr>
-                        <a:t>SEED-V</a:t>
-                      </a:r>
-                    </a:p>
-                  </a:txBody>
-                  <a:tcPr>
-                    <a:solidFill>
-                      <a:srgbClr val="FFFFFF"/>
-                    </a:solidFill>
-                  </a:tcPr>
-                </a:tc>
-                <a:tc>
-                  <a:txBody>
-                    <a:bodyPr/>
-                    <a:lstStyle/>
-                    <a:p>
-                      <a:pPr algn="l"/>
-                      <a:r>
-                        <a:rPr sz="1000" b="0">
-                          <a:solidFill>
-                            <a:srgbClr val="000000"/>
-                          </a:solidFill>
-                        </a:rPr>
-                        <a:t>Emotion</a:t>
-                      </a:r>
-                    </a:p>
-                  </a:txBody>
-                  <a:tcPr>
-                    <a:solidFill>
-                      <a:srgbClr val="F5F5F5"/>
-                    </a:solidFill>
-                  </a:tcPr>
-                </a:tc>
-                <a:tc>
-                  <a:txBody>
-                    <a:bodyPr/>
-                    <a:lstStyle/>
-                    <a:p>
-                      <a:pPr algn="ctr"/>
-                      <a:r>
-                        <a:rPr sz="1000" b="0">
-                          <a:solidFill>
-                            <a:srgbClr val="C8C8C8"/>
-                          </a:solidFill>
-                        </a:rPr>
-                        <a:t>--</a:t>
-                      </a:r>
-                    </a:p>
-                  </a:txBody>
-                  <a:tcPr>
-                    <a:solidFill>
-                      <a:srgbClr val="F5F5F5"/>
-                    </a:solidFill>
-                  </a:tcPr>
-                </a:tc>
-                <a:tc>
-                  <a:txBody>
-                    <a:bodyPr/>
-                    <a:lstStyle/>
-                    <a:p>
-                      <a:pPr algn="ctr"/>
-                      <a:r>
-                        <a:rPr sz="1000" b="0">
-                          <a:solidFill>
-                            <a:srgbClr val="C8C8C8"/>
-                          </a:solidFill>
-                        </a:rPr>
-                        <a:t>--</a:t>
-                      </a:r>
-                    </a:p>
-                  </a:txBody>
-                  <a:tcPr>
-                    <a:solidFill>
-                      <a:srgbClr val="F5F5F5"/>
-                    </a:solidFill>
-                  </a:tcPr>
-                </a:tc>
-                <a:tc>
-                  <a:txBody>
-                    <a:bodyPr/>
-                    <a:lstStyle/>
-                    <a:p>
-                      <a:pPr algn="ctr"/>
-                      <a:r>
-                        <a:rPr sz="1000" b="1">
-                          <a:solidFill>
-                            <a:srgbClr val="F1C40F"/>
-                          </a:solidFill>
-                        </a:rPr>
-                        <a:t>bAcc 0.402</a:t>
-                      </a:r>
-                    </a:p>
-                  </a:txBody>
-                  <a:tcPr>
-                    <a:solidFill>
-                      <a:srgbClr val="FFFADC"/>
-                    </a:solidFill>
-                  </a:tcPr>
-                </a:tc>
-              </a:tr>
-              <a:tr h="502920">
-                <a:tc>
-                  <a:txBody>
-                    <a:bodyPr/>
-                    <a:lstStyle/>
-                    <a:p>
-                      <a:pPr algn="l"/>
-                      <a:r>
-                        <a:rPr sz="1100" b="1">
-                          <a:solidFill>
-                            <a:srgbClr val="000000"/>
-                          </a:solidFill>
-                        </a:rPr>
-                        <a:t>SHU-MI</a:t>
-                      </a:r>
-                    </a:p>
-                  </a:txBody>
-                  <a:tcPr>
-                    <a:solidFill>
-                      <a:srgbClr val="FFFFFF"/>
-                    </a:solidFill>
-                  </a:tcPr>
-                </a:tc>
-                <a:tc>
-                  <a:txBody>
-                    <a:bodyPr/>
-                    <a:lstStyle/>
-                    <a:p>
-                      <a:pPr algn="l"/>
-                      <a:r>
-                        <a:rPr sz="1000" b="0">
-                          <a:solidFill>
-                            <a:srgbClr val="000000"/>
-                          </a:solidFill>
-                        </a:rPr>
-                        <a:t>Motor Imagery</a:t>
-                      </a:r>
-                    </a:p>
-                  </a:txBody>
-                  <a:tcPr>
-                    <a:solidFill>
-                      <a:srgbClr val="F5F5F5"/>
-                    </a:solidFill>
-                  </a:tcPr>
-                </a:tc>
-                <a:tc>
-                  <a:txBody>
-                    <a:bodyPr/>
-                    <a:lstStyle/>
-                    <a:p>
-                      <a:pPr algn="ctr"/>
-                      <a:r>
-                        <a:rPr sz="1000" b="0">
-                          <a:solidFill>
-                            <a:srgbClr val="C8C8C8"/>
-                          </a:solidFill>
-                        </a:rPr>
-                        <a:t>--</a:t>
-                      </a:r>
-                    </a:p>
-                  </a:txBody>
-                  <a:tcPr>
-                    <a:solidFill>
-                      <a:srgbClr val="F5F5F5"/>
-                    </a:solidFill>
-                  </a:tcPr>
-                </a:tc>
-                <a:tc>
-                  <a:txBody>
-                    <a:bodyPr/>
-                    <a:lstStyle/>
-                    <a:p>
-                      <a:pPr algn="ctr"/>
-                      <a:r>
-                        <a:rPr sz="1000" b="0">
-                          <a:solidFill>
-                            <a:srgbClr val="C8C8C8"/>
-                          </a:solidFill>
-                        </a:rPr>
-                        <a:t>--</a:t>
-                      </a:r>
-                    </a:p>
-                  </a:txBody>
-                  <a:tcPr>
-                    <a:solidFill>
-                      <a:srgbClr val="F5F5F5"/>
-                    </a:solidFill>
-                  </a:tcPr>
-                </a:tc>
-                <a:tc>
-                  <a:txBody>
-                    <a:bodyPr/>
-                    <a:lstStyle/>
-                    <a:p>
-                      <a:pPr algn="ctr"/>
-                      <a:r>
-                        <a:rPr sz="1000" b="1">
-                          <a:solidFill>
-                            <a:srgbClr val="27AE60"/>
-                          </a:solidFill>
-                        </a:rPr>
-                        <a:t>bAcc 0.638</a:t>
-                      </a:r>
-                    </a:p>
-                  </a:txBody>
-                  <a:tcPr>
-                    <a:solidFill>
-                      <a:srgbClr val="DCFFE6"/>
-                    </a:solidFill>
-                  </a:tcPr>
-                </a:tc>
-              </a:tr>
-              <a:tr h="502920">
-                <a:tc>
-                  <a:txBody>
-                    <a:bodyPr/>
-                    <a:lstStyle/>
-                    <a:p>
-                      <a:pPr algn="l"/>
-                      <a:r>
-                        <a:rPr sz="1100" b="1">
-                          <a:solidFill>
-                            <a:srgbClr val="000000"/>
-                          </a:solidFill>
-                        </a:rPr>
-                        <a:t>MDD</a:t>
-                      </a:r>
-                    </a:p>
-                  </a:txBody>
-                  <a:tcPr>
-                    <a:solidFill>
-                      <a:srgbClr val="FFFFFF"/>
-                    </a:solidFill>
-                  </a:tcPr>
-                </a:tc>
-                <a:tc>
-                  <a:txBody>
-                    <a:bodyPr/>
-                    <a:lstStyle/>
-                    <a:p>
-                      <a:pPr algn="l"/>
-                      <a:r>
-                        <a:rPr sz="1000" b="0">
-                          <a:solidFill>
-                            <a:srgbClr val="000000"/>
-                          </a:solidFill>
-                        </a:rPr>
-                        <a:t>Clinical</a:t>
-                      </a:r>
-                    </a:p>
-                  </a:txBody>
-                  <a:tcPr>
-                    <a:solidFill>
-                      <a:srgbClr val="F5F5F5"/>
-                    </a:solidFill>
-                  </a:tcPr>
-                </a:tc>
-                <a:tc>
-                  <a:txBody>
-                    <a:bodyPr/>
-                    <a:lstStyle/>
-                    <a:p>
-                      <a:pPr algn="ctr"/>
-                      <a:r>
-                        <a:rPr sz="1000" b="0">
-                          <a:solidFill>
-                            <a:srgbClr val="C8C8C8"/>
-                          </a:solidFill>
-                        </a:rPr>
-                        <a:t>--</a:t>
-                      </a:r>
-                    </a:p>
-                  </a:txBody>
-                  <a:tcPr>
-                    <a:solidFill>
-                      <a:srgbClr val="F5F5F5"/>
-                    </a:solidFill>
-                  </a:tcPr>
-                </a:tc>
-                <a:tc>
-                  <a:txBody>
-                    <a:bodyPr/>
-                    <a:lstStyle/>
-                    <a:p>
-                      <a:pPr algn="ctr"/>
-                      <a:r>
-                        <a:rPr sz="1000" b="0">
-                          <a:solidFill>
-                            <a:srgbClr val="C8C8C8"/>
-                          </a:solidFill>
-                        </a:rPr>
-                        <a:t>--</a:t>
-                      </a:r>
-                    </a:p>
-                  </a:txBody>
-                  <a:tcPr>
-                    <a:solidFill>
-                      <a:srgbClr val="F5F5F5"/>
-                    </a:solidFill>
-                  </a:tcPr>
-                </a:tc>
-                <a:tc>
-                  <a:txBody>
-                    <a:bodyPr/>
-                    <a:lstStyle/>
-                    <a:p>
-                      <a:pPr algn="ctr"/>
-                      <a:r>
-                        <a:rPr sz="1000" b="1">
-                          <a:solidFill>
-                            <a:srgbClr val="27AE60"/>
-                          </a:solidFill>
-                        </a:rPr>
-                        <a:t>bAcc 0.967</a:t>
-                      </a:r>
-                    </a:p>
-                  </a:txBody>
-                  <a:tcPr>
-                    <a:solidFill>
-                      <a:srgbClr val="DCFFE6"/>
-                    </a:solidFill>
-                  </a:tcPr>
-                </a:tc>
-              </a:tr>
-              <a:tr h="502920">
-                <a:tc>
-                  <a:txBody>
-                    <a:bodyPr/>
-                    <a:lstStyle/>
-                    <a:p>
-                      <a:pPr algn="l"/>
-                      <a:r>
-                        <a:rPr sz="1100" b="1">
-                          <a:solidFill>
-                            <a:srgbClr val="000000"/>
-                          </a:solidFill>
-                        </a:rPr>
-                        <a:t>TUEV</a:t>
-                      </a:r>
-                    </a:p>
-                  </a:txBody>
-                  <a:tcPr>
-                    <a:solidFill>
-                      <a:srgbClr val="FFFFFF"/>
-                    </a:solidFill>
-                  </a:tcPr>
-                </a:tc>
-                <a:tc>
-                  <a:txBody>
-                    <a:bodyPr/>
-                    <a:lstStyle/>
-                    <a:p>
-                      <a:pPr algn="l"/>
-                      <a:r>
-                        <a:rPr sz="1000" b="0">
-                          <a:solidFill>
-                            <a:srgbClr val="000000"/>
-                          </a:solidFill>
-                        </a:rPr>
-                        <a:t>Pathology</a:t>
-                      </a:r>
-                    </a:p>
-                  </a:txBody>
-                  <a:tcPr>
-                    <a:solidFill>
-                      <a:srgbClr val="F5F5F5"/>
-                    </a:solidFill>
-                  </a:tcPr>
-                </a:tc>
-                <a:tc>
-                  <a:txBody>
-                    <a:bodyPr/>
-                    <a:lstStyle/>
-                    <a:p>
-                      <a:pPr algn="ctr"/>
-                      <a:r>
-                        <a:rPr sz="1000" b="0">
-                          <a:solidFill>
-                            <a:srgbClr val="C8C8C8"/>
-                          </a:solidFill>
-                        </a:rPr>
-                        <a:t>--</a:t>
-                      </a:r>
-                    </a:p>
-                  </a:txBody>
-                  <a:tcPr>
-                    <a:solidFill>
-                      <a:srgbClr val="F5F5F5"/>
-                    </a:solidFill>
-                  </a:tcPr>
-                </a:tc>
-                <a:tc>
-                  <a:txBody>
-                    <a:bodyPr/>
-                    <a:lstStyle/>
-                    <a:p>
-                      <a:pPr algn="ctr"/>
-                      <a:r>
-                        <a:rPr sz="1000" b="0">
-                          <a:solidFill>
-                            <a:srgbClr val="C8C8C8"/>
-                          </a:solidFill>
-                        </a:rPr>
-                        <a:t>--</a:t>
-                      </a:r>
-                    </a:p>
-                  </a:txBody>
-                  <a:tcPr>
-                    <a:solidFill>
-                      <a:srgbClr val="F5F5F5"/>
-                    </a:solidFill>
-                  </a:tcPr>
-                </a:tc>
-                <a:tc>
-                  <a:txBody>
-                    <a:bodyPr/>
-                    <a:lstStyle/>
-                    <a:p>
-                      <a:pPr algn="ctr"/>
-                      <a:r>
-                        <a:rPr sz="1000" b="1">
-                          <a:solidFill>
-                            <a:srgbClr val="E74C3C"/>
-                          </a:solidFill>
-                        </a:rPr>
-                        <a:t>k 0.634</a:t>
-                      </a:r>
-                    </a:p>
-                  </a:txBody>
-                  <a:tcPr>
-                    <a:solidFill>
-                      <a:srgbClr val="FFE6E6"/>
                     </a:solidFill>
                   </a:tcPr>
                 </a:tc>
@@ -9733,14 +9830,14 @@
       </p:graphicFrame>
       <p:sp>
         <p:nvSpPr>
-          <p:cNvPr id="4" name="TextBox 3"/>
+          <p:cNvPr id="3" name="TextBox 2"/>
           <p:cNvSpPr txBox="1"/>
           <p:nvPr/>
         </p:nvSpPr>
         <p:spPr>
           <a:xfrm>
-            <a:off x="457200" y="6583680"/>
-            <a:ext cx="15544800" cy="274320"/>
+            <a:off x="274320" y="9281160"/>
+            <a:ext cx="16916400" cy="548640"/>
           </a:xfrm>
           <a:prstGeom prst="rect">
             <a:avLst/>
@@ -9748,528 +9845,32 @@
           <a:noFill/>
         </p:spPr>
         <p:txBody>
-          <a:bodyPr wrap="none">
+          <a:bodyPr wrap="square">
             <a:spAutoFit/>
           </a:bodyPr>
           <a:lstStyle/>
           <a:p>
             <a:r>
-              <a:rPr sz="1200" b="1"/>
-              <a:t>Legend:  </a:t>
-            </a:r>
-            <a:r>
-              <a:rPr sz="1100">
-                <a:solidFill>
-                  <a:srgbClr val="27AE60"/>
-                </a:solidFill>
-              </a:rPr>
-              <a:t>Green = On/above paper reference (reproduced)</a:t>
-            </a:r>
-            <a:r>
-              <a:rPr sz="1100">
-                <a:solidFill>
-                  <a:srgbClr val="B48200"/>
-                </a:solidFill>
-              </a:rPr>
-              <a:t>  |  Yellow = Close to paper reference</a:t>
-            </a:r>
-            <a:r>
-              <a:rPr sz="1100">
-                <a:solidFill>
-                  <a:srgbClr val="E74C3C"/>
-                </a:solidFill>
-              </a:rPr>
-              <a:t>  |  Red = Below paper reference</a:t>
-            </a:r>
-            <a:r>
-              <a:rPr sz="1100">
+              <a:rPr sz="900">
                 <a:solidFill>
                   <a:srgbClr val="C8C8C8"/>
                 </a:solidFill>
               </a:rPr>
-              <a:t>  |  Gray = No data</a:t>
+              <a:t>Sources: EEGNet — Lawhern et al., J. Neural Eng. 2018 (BCICIV2A ~68% within-subj, BCICIV2B ~80% test). EEG Conformer — Song et al., IEEE TNSRE 2023 (BCICIV2A 78.66% avg). CBraMod — Wang et al., ICLR 2025 (reference values from original paper).</a:t>
+            </a:r>
+          </a:p>
+          <a:p>
+            <a:r>
+              <a:rPr sz="900">
+                <a:solidFill>
+                  <a:srgbClr val="C8C8C8"/>
+                </a:solidFill>
+              </a:rPr>
+              <a:t>G = meets/exceeds paper reference (reproduced). Y = close to paper reference (within ~5%). R = below paper reference. No data = dataset not in paper or no test labels available. IIIa &amp; Physionet-MI were not in the original EEGNet paper.</a:t>
             </a:r>
           </a:p>
         </p:txBody>
       </p:sp>
-      <p:graphicFrame>
-        <p:nvGraphicFramePr>
-          <p:cNvPr id="5" name="Table 4"/>
-          <p:cNvGraphicFramePr>
-            <a:graphicFrameLocks noGrp="1"/>
-          </p:cNvGraphicFramePr>
-          <p:nvPr/>
-        </p:nvGraphicFramePr>
-        <p:xfrm>
-          <a:off x="457200" y="7040880"/>
-          <a:ext cx="13350240" cy="1828800"/>
-        </p:xfrm>
-        <a:graphic>
-          <a:graphicData uri="http://schemas.openxmlformats.org/drawingml/2006/table">
-            <a:tbl>
-              <a:tblPr firstRow="1" bandRow="1">
-                <a:tableStyleId>{5C22544A-7EE6-4342-B048-85BDC9FD1C3A}</a:tableStyleId>
-              </a:tblPr>
-              <a:tblGrid>
-                <a:gridCol w="1828800"/>
-                <a:gridCol w="3840480"/>
-                <a:gridCol w="3840480"/>
-                <a:gridCol w="3840480"/>
-              </a:tblGrid>
-              <a:tr h="365760">
-                <a:tc>
-                  <a:txBody>
-                    <a:bodyPr/>
-                    <a:lstStyle/>
-                    <a:p>
-                      <a:pPr algn="ctr"/>
-                      <a:r>
-                        <a:rPr sz="1100" b="1">
-                          <a:solidFill>
-                            <a:srgbClr val="FFFFFF"/>
-                          </a:solidFill>
-                        </a:rPr>
-                        <a:t/>
-                      </a:r>
-                    </a:p>
-                  </a:txBody>
-                  <a:tcPr>
-                    <a:solidFill>
-                      <a:srgbClr val="3C3C3C"/>
-                    </a:solidFill>
-                  </a:tcPr>
-                </a:tc>
-                <a:tc>
-                  <a:txBody>
-                    <a:bodyPr/>
-                    <a:lstStyle/>
-                    <a:p>
-                      <a:pPr algn="ctr"/>
-                      <a:r>
-                        <a:rPr sz="1100" b="1">
-                          <a:solidFill>
-                            <a:srgbClr val="FFFFFF"/>
-                          </a:solidFill>
-                        </a:rPr>
-                        <a:t>EEGNet</a:t>
-                      </a:r>
-                    </a:p>
-                  </a:txBody>
-                  <a:tcPr>
-                    <a:solidFill>
-                      <a:srgbClr val="3C3C3C"/>
-                    </a:solidFill>
-                  </a:tcPr>
-                </a:tc>
-                <a:tc>
-                  <a:txBody>
-                    <a:bodyPr/>
-                    <a:lstStyle/>
-                    <a:p>
-                      <a:pPr algn="ctr"/>
-                      <a:r>
-                        <a:rPr sz="1100" b="1">
-                          <a:solidFill>
-                            <a:srgbClr val="FFFFFF"/>
-                          </a:solidFill>
-                        </a:rPr>
-                        <a:t>EEG Conformer</a:t>
-                      </a:r>
-                    </a:p>
-                  </a:txBody>
-                  <a:tcPr>
-                    <a:solidFill>
-                      <a:srgbClr val="3C3C3C"/>
-                    </a:solidFill>
-                  </a:tcPr>
-                </a:tc>
-                <a:tc>
-                  <a:txBody>
-                    <a:bodyPr/>
-                    <a:lstStyle/>
-                    <a:p>
-                      <a:pPr algn="ctr"/>
-                      <a:r>
-                        <a:rPr sz="1100" b="1">
-                          <a:solidFill>
-                            <a:srgbClr val="FFFFFF"/>
-                          </a:solidFill>
-                        </a:rPr>
-                        <a:t>CBraMod</a:t>
-                      </a:r>
-                    </a:p>
-                  </a:txBody>
-                  <a:tcPr>
-                    <a:solidFill>
-                      <a:srgbClr val="3C3C3C"/>
-                    </a:solidFill>
-                  </a:tcPr>
-                </a:tc>
-              </a:tr>
-              <a:tr h="365760">
-                <a:tc>
-                  <a:txBody>
-                    <a:bodyPr/>
-                    <a:lstStyle/>
-                    <a:p>
-                      <a:pPr algn="l"/>
-                      <a:r>
-                        <a:rPr sz="1100" b="1">
-                          <a:solidFill>
-                            <a:srgbClr val="27AE60"/>
-                          </a:solidFill>
-                        </a:rPr>
-                        <a:t>Green (reproduced)</a:t>
-                      </a:r>
-                    </a:p>
-                  </a:txBody>
-                  <a:tcPr>
-                    <a:solidFill>
-                      <a:srgbClr val="FFFFFF"/>
-                    </a:solidFill>
-                  </a:tcPr>
-                </a:tc>
-                <a:tc>
-                  <a:txBody>
-                    <a:bodyPr/>
-                    <a:lstStyle/>
-                    <a:p>
-                      <a:pPr algn="ctr"/>
-                      <a:r>
-                        <a:rPr sz="1200" b="1">
-                          <a:solidFill>
-                            <a:srgbClr val="27AE60"/>
-                          </a:solidFill>
-                        </a:rPr>
-                        <a:t>2</a:t>
-                      </a:r>
-                    </a:p>
-                  </a:txBody>
-                  <a:tcPr>
-                    <a:solidFill>
-                      <a:srgbClr val="DCFFE6"/>
-                    </a:solidFill>
-                  </a:tcPr>
-                </a:tc>
-                <a:tc>
-                  <a:txBody>
-                    <a:bodyPr/>
-                    <a:lstStyle/>
-                    <a:p>
-                      <a:pPr algn="ctr"/>
-                      <a:r>
-                        <a:rPr sz="1200" b="1">
-                          <a:solidFill>
-                            <a:srgbClr val="27AE60"/>
-                          </a:solidFill>
-                        </a:rPr>
-                        <a:t>1</a:t>
-                      </a:r>
-                    </a:p>
-                  </a:txBody>
-                  <a:tcPr>
-                    <a:solidFill>
-                      <a:srgbClr val="DCFFE6"/>
-                    </a:solidFill>
-                  </a:tcPr>
-                </a:tc>
-                <a:tc>
-                  <a:txBody>
-                    <a:bodyPr/>
-                    <a:lstStyle/>
-                    <a:p>
-                      <a:pPr algn="ctr"/>
-                      <a:r>
-                        <a:rPr sz="1200" b="1">
-                          <a:solidFill>
-                            <a:srgbClr val="27AE60"/>
-                          </a:solidFill>
-                        </a:rPr>
-                        <a:t>4</a:t>
-                      </a:r>
-                    </a:p>
-                  </a:txBody>
-                  <a:tcPr>
-                    <a:solidFill>
-                      <a:srgbClr val="DCFFE6"/>
-                    </a:solidFill>
-                  </a:tcPr>
-                </a:tc>
-              </a:tr>
-              <a:tr h="365760">
-                <a:tc>
-                  <a:txBody>
-                    <a:bodyPr/>
-                    <a:lstStyle/>
-                    <a:p>
-                      <a:pPr algn="l"/>
-                      <a:r>
-                        <a:rPr sz="1100" b="1">
-                          <a:solidFill>
-                            <a:srgbClr val="B48200"/>
-                          </a:solidFill>
-                        </a:rPr>
-                        <a:t>Yellow (close)</a:t>
-                      </a:r>
-                    </a:p>
-                  </a:txBody>
-                  <a:tcPr>
-                    <a:solidFill>
-                      <a:srgbClr val="FFFFFF"/>
-                    </a:solidFill>
-                  </a:tcPr>
-                </a:tc>
-                <a:tc>
-                  <a:txBody>
-                    <a:bodyPr/>
-                    <a:lstStyle/>
-                    <a:p>
-                      <a:pPr algn="ctr"/>
-                      <a:r>
-                        <a:rPr sz="1200" b="1">
-                          <a:solidFill>
-                            <a:srgbClr val="B48200"/>
-                          </a:solidFill>
-                        </a:rPr>
-                        <a:t>2</a:t>
-                      </a:r>
-                    </a:p>
-                  </a:txBody>
-                  <a:tcPr>
-                    <a:solidFill>
-                      <a:srgbClr val="FFFADC"/>
-                    </a:solidFill>
-                  </a:tcPr>
-                </a:tc>
-                <a:tc>
-                  <a:txBody>
-                    <a:bodyPr/>
-                    <a:lstStyle/>
-                    <a:p>
-                      <a:pPr algn="ctr"/>
-                      <a:r>
-                        <a:rPr sz="1200" b="0">
-                          <a:solidFill>
-                            <a:srgbClr val="B48200"/>
-                          </a:solidFill>
-                        </a:rPr>
-                        <a:t>0</a:t>
-                      </a:r>
-                    </a:p>
-                  </a:txBody>
-                  <a:tcPr>
-                    <a:solidFill>
-                      <a:srgbClr val="FFFADC"/>
-                    </a:solidFill>
-                  </a:tcPr>
-                </a:tc>
-                <a:tc>
-                  <a:txBody>
-                    <a:bodyPr/>
-                    <a:lstStyle/>
-                    <a:p>
-                      <a:pPr algn="ctr"/>
-                      <a:r>
-                        <a:rPr sz="1200" b="1">
-                          <a:solidFill>
-                            <a:srgbClr val="B48200"/>
-                          </a:solidFill>
-                        </a:rPr>
-                        <a:t>3</a:t>
-                      </a:r>
-                    </a:p>
-                  </a:txBody>
-                  <a:tcPr>
-                    <a:solidFill>
-                      <a:srgbClr val="FFFADC"/>
-                    </a:solidFill>
-                  </a:tcPr>
-                </a:tc>
-              </a:tr>
-              <a:tr h="365760">
-                <a:tc>
-                  <a:txBody>
-                    <a:bodyPr/>
-                    <a:lstStyle/>
-                    <a:p>
-                      <a:pPr algn="l"/>
-                      <a:r>
-                        <a:rPr sz="1100" b="1">
-                          <a:solidFill>
-                            <a:srgbClr val="E74C3C"/>
-                          </a:solidFill>
-                        </a:rPr>
-                        <a:t>Red (below)</a:t>
-                      </a:r>
-                    </a:p>
-                  </a:txBody>
-                  <a:tcPr>
-                    <a:solidFill>
-                      <a:srgbClr val="FFFFFF"/>
-                    </a:solidFill>
-                  </a:tcPr>
-                </a:tc>
-                <a:tc>
-                  <a:txBody>
-                    <a:bodyPr/>
-                    <a:lstStyle/>
-                    <a:p>
-                      <a:pPr algn="ctr"/>
-                      <a:r>
-                        <a:rPr sz="1200" b="0">
-                          <a:solidFill>
-                            <a:srgbClr val="E74C3C"/>
-                          </a:solidFill>
-                        </a:rPr>
-                        <a:t>0</a:t>
-                      </a:r>
-                    </a:p>
-                  </a:txBody>
-                  <a:tcPr>
-                    <a:solidFill>
-                      <a:srgbClr val="FFE6E6"/>
-                    </a:solidFill>
-                  </a:tcPr>
-                </a:tc>
-                <a:tc>
-                  <a:txBody>
-                    <a:bodyPr/>
-                    <a:lstStyle/>
-                    <a:p>
-                      <a:pPr algn="ctr"/>
-                      <a:r>
-                        <a:rPr sz="1200" b="0">
-                          <a:solidFill>
-                            <a:srgbClr val="E74C3C"/>
-                          </a:solidFill>
-                        </a:rPr>
-                        <a:t>0</a:t>
-                      </a:r>
-                    </a:p>
-                  </a:txBody>
-                  <a:tcPr>
-                    <a:solidFill>
-                      <a:srgbClr val="FFE6E6"/>
-                    </a:solidFill>
-                  </a:tcPr>
-                </a:tc>
-                <a:tc>
-                  <a:txBody>
-                    <a:bodyPr/>
-                    <a:lstStyle/>
-                    <a:p>
-                      <a:pPr algn="ctr"/>
-                      <a:r>
-                        <a:rPr sz="1200" b="1">
-                          <a:solidFill>
-                            <a:srgbClr val="E74C3C"/>
-                          </a:solidFill>
-                        </a:rPr>
-                        <a:t>1</a:t>
-                      </a:r>
-                    </a:p>
-                  </a:txBody>
-                  <a:tcPr>
-                    <a:solidFill>
-                      <a:srgbClr val="FFE6E6"/>
-                    </a:solidFill>
-                  </a:tcPr>
-                </a:tc>
-              </a:tr>
-              <a:tr h="365760">
-                <a:tc>
-                  <a:txBody>
-                    <a:bodyPr/>
-                    <a:lstStyle/>
-                    <a:p>
-                      <a:pPr algn="l"/>
-                      <a:r>
-                        <a:rPr sz="1100" b="1">
-                          <a:solidFill>
-                            <a:srgbClr val="C8C8C8"/>
-                          </a:solidFill>
-                        </a:rPr>
-                        <a:t>No data</a:t>
-                      </a:r>
-                    </a:p>
-                  </a:txBody>
-                  <a:tcPr>
-                    <a:solidFill>
-                      <a:srgbClr val="FFFFFF"/>
-                    </a:solidFill>
-                  </a:tcPr>
-                </a:tc>
-                <a:tc>
-                  <a:txBody>
-                    <a:bodyPr/>
-                    <a:lstStyle/>
-                    <a:p>
-                      <a:pPr algn="ctr"/>
-                      <a:r>
-                        <a:rPr sz="1200" b="0">
-                          <a:solidFill>
-                            <a:srgbClr val="C8C8C8"/>
-                          </a:solidFill>
-                        </a:rPr>
-                        <a:t>0</a:t>
-                      </a:r>
-                    </a:p>
-                  </a:txBody>
-                  <a:tcPr>
-                    <a:solidFill>
-                      <a:srgbClr val="F5F5F5"/>
-                    </a:solidFill>
-                  </a:tcPr>
-                </a:tc>
-                <a:tc>
-                  <a:txBody>
-                    <a:bodyPr/>
-                    <a:lstStyle/>
-                    <a:p>
-                      <a:pPr algn="ctr"/>
-                      <a:r>
-                        <a:rPr sz="1200" b="1">
-                          <a:solidFill>
-                            <a:srgbClr val="C8C8C8"/>
-                          </a:solidFill>
-                        </a:rPr>
-                        <a:t>3</a:t>
-                      </a:r>
-                    </a:p>
-                  </a:txBody>
-                  <a:tcPr>
-                    <a:solidFill>
-                      <a:srgbClr val="F5F5F5"/>
-                    </a:solidFill>
-                  </a:tcPr>
-                </a:tc>
-                <a:tc>
-                  <a:txBody>
-                    <a:bodyPr/>
-                    <a:lstStyle/>
-                    <a:p>
-                      <a:pPr algn="ctr"/>
-                      <a:r>
-                        <a:rPr sz="1200" b="1">
-                          <a:solidFill>
-                            <a:srgbClr val="C8C8C8"/>
-                          </a:solidFill>
-                        </a:rPr>
-                        <a:t>2</a:t>
-                      </a:r>
-                    </a:p>
-                  </a:txBody>
-                  <a:tcPr>
-                    <a:solidFill>
-                      <a:srgbClr val="F5F5F5"/>
-                    </a:solidFill>
-                  </a:tcPr>
-                </a:tc>
-              </a:tr>
-            </a:tbl>
-          </a:graphicData>
-        </a:graphic>
-      </p:graphicFrame>
     </p:spTree>
   </p:cSld>
   <p:clrMapOvr>

</xml_diff>